<commit_message>
Review composition revisions and tighten evidence-density guidance
</commit_message>
<xml_diff>
--- a/experiments/university-skin-pilot/aesthetic-ab-01/composition-product-a/round-01/deck.pptx
+++ b/experiments/university-skin-pilot/aesthetic-ab-01/composition-product-a/round-01/deck.pptx
@@ -2,23 +2,23 @@
 <file path=ppt/presentation.xml><?xml version="1.0" encoding="utf-8"?>
 <p:presentation xmlns:p="http://schemas.openxmlformats.org/presentationml/2006/main">
   <p:sldMasterIdLst>
-    <p:sldMasterId xmlns:r="http://schemas.openxmlformats.org/officeDocument/2006/relationships" id="2147483648" r:id="R7e028fe00c194031"/>
+    <p:sldMasterId xmlns:r="http://schemas.openxmlformats.org/officeDocument/2006/relationships" id="2147483648" r:id="R1b3904d117194ebb"/>
   </p:sldMasterIdLst>
   <p:notesMasterIdLst>
-    <p:notesMasterId xmlns:r="http://schemas.openxmlformats.org/officeDocument/2006/relationships" r:id="R2e46d0fdc720405a"/>
+    <p:notesMasterId xmlns:r="http://schemas.openxmlformats.org/officeDocument/2006/relationships" r:id="R3f7dd37ee2e64c14"/>
   </p:notesMasterIdLst>
   <p:sldIdLst>
-    <p:sldId xmlns:r="http://schemas.openxmlformats.org/officeDocument/2006/relationships" id="256" r:id="R22d159d5f7c54ea6"/>
-    <p:sldId xmlns:r="http://schemas.openxmlformats.org/officeDocument/2006/relationships" id="257" r:id="Rf8c8d0030f4840b0"/>
-    <p:sldId xmlns:r="http://schemas.openxmlformats.org/officeDocument/2006/relationships" id="258" r:id="R73088f6eadcb4879"/>
-    <p:sldId xmlns:r="http://schemas.openxmlformats.org/officeDocument/2006/relationships" id="259" r:id="R63a15db770ef4828"/>
-    <p:sldId xmlns:r="http://schemas.openxmlformats.org/officeDocument/2006/relationships" id="260" r:id="R63420f6f19074b7b"/>
-    <p:sldId xmlns:r="http://schemas.openxmlformats.org/officeDocument/2006/relationships" id="261" r:id="Rb261a9f2dc544222"/>
-    <p:sldId xmlns:r="http://schemas.openxmlformats.org/officeDocument/2006/relationships" id="262" r:id="R147a0d9266ce4c80"/>
-    <p:sldId xmlns:r="http://schemas.openxmlformats.org/officeDocument/2006/relationships" id="263" r:id="R2ea653eb26014c71"/>
-    <p:sldId xmlns:r="http://schemas.openxmlformats.org/officeDocument/2006/relationships" id="264" r:id="Rc6e429f8b7d442e9"/>
-    <p:sldId xmlns:r="http://schemas.openxmlformats.org/officeDocument/2006/relationships" id="265" r:id="R9fd7062b699e466b"/>
-    <p:sldId xmlns:r="http://schemas.openxmlformats.org/officeDocument/2006/relationships" id="266" r:id="R822f14d85d804713"/>
+    <p:sldId xmlns:r="http://schemas.openxmlformats.org/officeDocument/2006/relationships" id="256" r:id="Rf991aad360644c61"/>
+    <p:sldId xmlns:r="http://schemas.openxmlformats.org/officeDocument/2006/relationships" id="257" r:id="R1bcd455f216e4cbb"/>
+    <p:sldId xmlns:r="http://schemas.openxmlformats.org/officeDocument/2006/relationships" id="258" r:id="Rebb6600408354859"/>
+    <p:sldId xmlns:r="http://schemas.openxmlformats.org/officeDocument/2006/relationships" id="259" r:id="Ra7f86e4eb2c64b40"/>
+    <p:sldId xmlns:r="http://schemas.openxmlformats.org/officeDocument/2006/relationships" id="260" r:id="Rfaa8c35423454c42"/>
+    <p:sldId xmlns:r="http://schemas.openxmlformats.org/officeDocument/2006/relationships" id="261" r:id="Rea0b398a6c6f485d"/>
+    <p:sldId xmlns:r="http://schemas.openxmlformats.org/officeDocument/2006/relationships" id="262" r:id="Ra4f656417f144f75"/>
+    <p:sldId xmlns:r="http://schemas.openxmlformats.org/officeDocument/2006/relationships" id="263" r:id="R1f091a300eb242a9"/>
+    <p:sldId xmlns:r="http://schemas.openxmlformats.org/officeDocument/2006/relationships" id="264" r:id="R040fb346243c410e"/>
+    <p:sldId xmlns:r="http://schemas.openxmlformats.org/officeDocument/2006/relationships" id="265" r:id="R767f3e5b1c9a4ea4"/>
+    <p:sldId xmlns:r="http://schemas.openxmlformats.org/officeDocument/2006/relationships" id="266" r:id="R4c416d5b817347d8"/>
   </p:sldIdLst>
   <p:sldSz cx="12192000" cy="6858000"/>
   <p:notesSz cx="6858000" cy="9144000"/>
@@ -1176,7 +1176,7 @@
   </p:cSld>
   <p:clrMap bg1="lt1" tx1="dk1" bg2="lt2" tx2="dk2" accent1="accent1" accent2="accent2" accent3="accent3" accent4="accent4" accent5="accent5" accent6="accent6" hlink="hlink" folHlink="folHlink"/>
   <p:sldLayoutIdLst>
-    <p:sldLayoutId xmlns:r="http://schemas.openxmlformats.org/officeDocument/2006/relationships" id="2147483649" r:id="Rda97591bfd1a4aac"/>
+    <p:sldLayoutId xmlns:r="http://schemas.openxmlformats.org/officeDocument/2006/relationships" id="2147483649" r:id="R79cad5eed5e344a6"/>
   </p:sldLayoutIdLst>
   <p:txStyles>
     <p:titleStyle>
@@ -1727,7 +1727,7 @@
           <p:cNvPr id="8" name="p1-accent">
             <a:extLst xmlns:a="http://schemas.openxmlformats.org/drawingml/2006/main">
               <a:ext uri="{FF2B5EF4-FFF2-40B4-BE49-F238E27FC236}">
-                <a16:creationId xmlns:a16="http://schemas.microsoft.com/office/drawing/2014/main" id="{79CC02B6-216D-48F8-BE04-E48ACF86E141}"/>
+                <a16:creationId xmlns:a16="http://schemas.microsoft.com/office/drawing/2014/main" id="{188E3DD4-9024-4981-8F29-2F1A14A7FB9D}"/>
               </a:ext>
             </a:extLst>
           </p:cNvPr>
@@ -1758,7 +1758,7 @@
           <p:cNvPr id="2" name="p1-kicker">
             <a:extLst xmlns:a="http://schemas.openxmlformats.org/drawingml/2006/main">
               <a:ext uri="{FF2B5EF4-FFF2-40B4-BE49-F238E27FC236}">
-                <a16:creationId xmlns:a16="http://schemas.microsoft.com/office/drawing/2014/main" id="{7027E09B-B69A-4B30-A608-19EAD3CB1A2A}"/>
+                <a16:creationId xmlns:a16="http://schemas.microsoft.com/office/drawing/2014/main" id="{192ABB8B-1E10-4516-9E1D-AF52EEF1B7CD}"/>
               </a:ext>
             </a:extLst>
           </p:cNvPr>
@@ -1820,7 +1820,7 @@
           <p:cNvPr id="3" name="p1-title">
             <a:extLst xmlns:a="http://schemas.openxmlformats.org/drawingml/2006/main">
               <a:ext uri="{FF2B5EF4-FFF2-40B4-BE49-F238E27FC236}">
-                <a16:creationId xmlns:a16="http://schemas.microsoft.com/office/drawing/2014/main" id="{4915008D-1AC8-40A2-9845-2B91116F03F1}"/>
+                <a16:creationId xmlns:a16="http://schemas.microsoft.com/office/drawing/2014/main" id="{B830A1C0-C451-424A-816E-D159A4DAB86B}"/>
               </a:ext>
             </a:extLst>
           </p:cNvPr>
@@ -1882,7 +1882,7 @@
           <p:cNvPr id="4" name="p1-subtitle">
             <a:extLst xmlns:a="http://schemas.openxmlformats.org/drawingml/2006/main">
               <a:ext uri="{FF2B5EF4-FFF2-40B4-BE49-F238E27FC236}">
-                <a16:creationId xmlns:a16="http://schemas.microsoft.com/office/drawing/2014/main" id="{DFA84354-F0B2-42F9-B763-EA2E24ECBDB3}"/>
+                <a16:creationId xmlns:a16="http://schemas.microsoft.com/office/drawing/2014/main" id="{D0746937-0763-41D1-A176-AAF72E11BE9F}"/>
               </a:ext>
             </a:extLst>
           </p:cNvPr>
@@ -1944,7 +1944,7 @@
           <p:cNvPr id="5" name="p1-divider">
             <a:extLst xmlns:a="http://schemas.openxmlformats.org/drawingml/2006/main">
               <a:ext uri="{FF2B5EF4-FFF2-40B4-BE49-F238E27FC236}">
-                <a16:creationId xmlns:a16="http://schemas.microsoft.com/office/drawing/2014/main" id="{9194B1CE-1256-4CF7-B5B8-E294DB447B7D}"/>
+                <a16:creationId xmlns:a16="http://schemas.microsoft.com/office/drawing/2014/main" id="{C0973186-5D26-40AB-879D-71B61C7239AA}"/>
               </a:ext>
             </a:extLst>
           </p:cNvPr>
@@ -1975,7 +1975,7 @@
           <p:cNvPr id="6" name="p1-foot">
             <a:extLst xmlns:a="http://schemas.openxmlformats.org/drawingml/2006/main">
               <a:ext uri="{FF2B5EF4-FFF2-40B4-BE49-F238E27FC236}">
-                <a16:creationId xmlns:a16="http://schemas.microsoft.com/office/drawing/2014/main" id="{BA78FEBF-2EC3-432B-B282-0F6C10A9254B}"/>
+                <a16:creationId xmlns:a16="http://schemas.microsoft.com/office/drawing/2014/main" id="{1B83FA6D-6D27-4C55-9E0A-CBB1C07C9E0B}"/>
               </a:ext>
             </a:extLst>
           </p:cNvPr>
@@ -2037,7 +2037,7 @@
           <p:cNvPr id="7" name="p1-page">
             <a:extLst xmlns:a="http://schemas.openxmlformats.org/drawingml/2006/main">
               <a:ext uri="{FF2B5EF4-FFF2-40B4-BE49-F238E27FC236}">
-                <a16:creationId xmlns:a16="http://schemas.microsoft.com/office/drawing/2014/main" id="{226BCB58-EA0B-40C9-A96C-A255964AC49C}"/>
+                <a16:creationId xmlns:a16="http://schemas.microsoft.com/office/drawing/2014/main" id="{48C4F360-68C0-4ECF-B1E8-7DD81E6DC647}"/>
               </a:ext>
             </a:extLst>
           </p:cNvPr>
@@ -2097,7 +2097,7 @@
     </p:spTree>
     <p:extLst>
       <p:ext uri="{BB962C8B-B14F-4D97-AF65-F5344CB8AC3E}">
-        <p14:creationId xmlns:p14="http://schemas.microsoft.com/office/powerpoint/2010/main" val="186861955"/>
+        <p14:creationId xmlns:p14="http://schemas.microsoft.com/office/powerpoint/2010/main" val="33087180"/>
       </p:ext>
     </p:extLst>
   </p:cSld>
@@ -2128,7 +2128,7 @@
           <p:cNvPr id="22" name="p10-eyebrow">
             <a:extLst xmlns:a="http://schemas.openxmlformats.org/drawingml/2006/main">
               <a:ext uri="{FF2B5EF4-FFF2-40B4-BE49-F238E27FC236}">
-                <a16:creationId xmlns:a16="http://schemas.microsoft.com/office/drawing/2014/main" id="{D0CBAD17-B910-45E0-B512-8166F3E2DBEA}"/>
+                <a16:creationId xmlns:a16="http://schemas.microsoft.com/office/drawing/2014/main" id="{09340E8F-D7C8-47DB-B00B-60E52C3A89FB}"/>
               </a:ext>
             </a:extLst>
           </p:cNvPr>
@@ -2162,7 +2162,7 @@
                 <a:spcPct val="140000"/>
               </a:lnSpc>
               <a:buNone/>
-              <a:defRPr sz="900" b="1">
+              <a:defRPr sz="900" b="0">
                 <a:solidFill>
                   <a:srgbClr val="315F91"/>
                 </a:solidFill>
@@ -2172,7 +2172,7 @@
               </a:defRPr>
             </a:pPr>
             <a:r>
-              <a:rPr sz="900" b="1">
+              <a:rPr sz="900" b="0">
                 <a:solidFill>
                   <a:srgbClr val="315F91"/>
                 </a:solidFill>
@@ -2190,7 +2190,7 @@
           <p:cNvPr id="2" name="p10-title">
             <a:extLst xmlns:a="http://schemas.openxmlformats.org/drawingml/2006/main">
               <a:ext uri="{FF2B5EF4-FFF2-40B4-BE49-F238E27FC236}">
-                <a16:creationId xmlns:a16="http://schemas.microsoft.com/office/drawing/2014/main" id="{9159FDAF-E15A-4359-AD5F-969752406695}"/>
+                <a16:creationId xmlns:a16="http://schemas.microsoft.com/office/drawing/2014/main" id="{E5A4A4C7-81C0-45B1-80FE-68575C145B5B}"/>
               </a:ext>
             </a:extLst>
           </p:cNvPr>
@@ -2252,7 +2252,7 @@
           <p:cNvPr id="3" name="p10-divider">
             <a:extLst xmlns:a="http://schemas.openxmlformats.org/drawingml/2006/main">
               <a:ext uri="{FF2B5EF4-FFF2-40B4-BE49-F238E27FC236}">
-                <a16:creationId xmlns:a16="http://schemas.microsoft.com/office/drawing/2014/main" id="{85FA96A5-E15F-4616-BF17-8D298D92DCAF}"/>
+                <a16:creationId xmlns:a16="http://schemas.microsoft.com/office/drawing/2014/main" id="{432D8290-4DA4-41B7-9A54-90FACC243E85}"/>
               </a:ext>
             </a:extLst>
           </p:cNvPr>
@@ -2283,7 +2283,7 @@
           <p:cNvPr id="4" name="p10-footer">
             <a:extLst xmlns:a="http://schemas.openxmlformats.org/drawingml/2006/main">
               <a:ext uri="{FF2B5EF4-FFF2-40B4-BE49-F238E27FC236}">
-                <a16:creationId xmlns:a16="http://schemas.microsoft.com/office/drawing/2014/main" id="{64F5DF7C-9C13-4262-9751-4381597EF273}"/>
+                <a16:creationId xmlns:a16="http://schemas.microsoft.com/office/drawing/2014/main" id="{B4B2E8ED-C599-4F6D-A324-0CB7BDD569C5}"/>
               </a:ext>
             </a:extLst>
           </p:cNvPr>
@@ -2345,7 +2345,7 @@
           <p:cNvPr id="5" name="p10-intro">
             <a:extLst xmlns:a="http://schemas.openxmlformats.org/drawingml/2006/main">
               <a:ext uri="{FF2B5EF4-FFF2-40B4-BE49-F238E27FC236}">
-                <a16:creationId xmlns:a16="http://schemas.microsoft.com/office/drawing/2014/main" id="{8ED595C7-02AD-4296-9F72-E2A5BA4CDD15}"/>
+                <a16:creationId xmlns:a16="http://schemas.microsoft.com/office/drawing/2014/main" id="{16F9BB3A-02F2-4D91-9A2E-37A9CF2557CF}"/>
               </a:ext>
             </a:extLst>
           </p:cNvPr>
@@ -2407,7 +2407,7 @@
           <p:cNvPr id="6" name="p10-in-0">
             <a:extLst xmlns:a="http://schemas.openxmlformats.org/drawingml/2006/main">
               <a:ext uri="{FF2B5EF4-FFF2-40B4-BE49-F238E27FC236}">
-                <a16:creationId xmlns:a16="http://schemas.microsoft.com/office/drawing/2014/main" id="{8713C2BE-29A6-473F-ABC4-1095F57D36B8}"/>
+                <a16:creationId xmlns:a16="http://schemas.microsoft.com/office/drawing/2014/main" id="{AD1F3188-1D40-4203-9B8C-5038213BCEB1}"/>
               </a:ext>
             </a:extLst>
           </p:cNvPr>
@@ -2438,7 +2438,7 @@
           <p:cNvPr id="7" name="p10-in-0-text">
             <a:extLst xmlns:a="http://schemas.openxmlformats.org/drawingml/2006/main">
               <a:ext uri="{FF2B5EF4-FFF2-40B4-BE49-F238E27FC236}">
-                <a16:creationId xmlns:a16="http://schemas.microsoft.com/office/drawing/2014/main" id="{54C95189-3437-4098-A17D-DD13CA17D4B8}"/>
+                <a16:creationId xmlns:a16="http://schemas.microsoft.com/office/drawing/2014/main" id="{43C5289D-98D1-435E-88D9-6A257E1B5FD0}"/>
               </a:ext>
             </a:extLst>
           </p:cNvPr>
@@ -2500,7 +2500,7 @@
           <p:cNvPr id="8" name="p10-path-0">
             <a:extLst xmlns:a="http://schemas.openxmlformats.org/drawingml/2006/main">
               <a:ext uri="{FF2B5EF4-FFF2-40B4-BE49-F238E27FC236}">
-                <a16:creationId xmlns:a16="http://schemas.microsoft.com/office/drawing/2014/main" id="{62C2CB4C-2B0E-40B2-8503-8BD465E8000A}"/>
+                <a16:creationId xmlns:a16="http://schemas.microsoft.com/office/drawing/2014/main" id="{74BDBF5F-B3E5-44C2-B788-3D99F2FA5007}"/>
               </a:ext>
             </a:extLst>
           </p:cNvPr>
@@ -2531,7 +2531,7 @@
           <p:cNvPr id="9" name="p10-in-1">
             <a:extLst xmlns:a="http://schemas.openxmlformats.org/drawingml/2006/main">
               <a:ext uri="{FF2B5EF4-FFF2-40B4-BE49-F238E27FC236}">
-                <a16:creationId xmlns:a16="http://schemas.microsoft.com/office/drawing/2014/main" id="{DEA0AA77-6F09-4FB5-AEF4-5D236D72BF33}"/>
+                <a16:creationId xmlns:a16="http://schemas.microsoft.com/office/drawing/2014/main" id="{1E3307C2-6AE6-4D1A-8480-EC98870C5943}"/>
               </a:ext>
             </a:extLst>
           </p:cNvPr>
@@ -2562,7 +2562,7 @@
           <p:cNvPr id="10" name="p10-in-1-text">
             <a:extLst xmlns:a="http://schemas.openxmlformats.org/drawingml/2006/main">
               <a:ext uri="{FF2B5EF4-FFF2-40B4-BE49-F238E27FC236}">
-                <a16:creationId xmlns:a16="http://schemas.microsoft.com/office/drawing/2014/main" id="{80A2057D-BE20-4B4B-A183-3FFD32C3639D}"/>
+                <a16:creationId xmlns:a16="http://schemas.microsoft.com/office/drawing/2014/main" id="{FFB51860-53B2-4E21-9F4A-5B89E55501E1}"/>
               </a:ext>
             </a:extLst>
           </p:cNvPr>
@@ -2614,7 +2614,7 @@
                 <a:ea typeface="Microsoft YaHei"/>
                 <a:cs typeface="Microsoft YaHei"/>
               </a:rPr>
-              <a:t>科研院所</a:t>
+              <a:t>科研院所 / 实验室</a:t>
             </a:r>
           </a:p>
         </p:txBody>
@@ -2624,7 +2624,7 @@
           <p:cNvPr id="11" name="p10-path-1">
             <a:extLst xmlns:a="http://schemas.openxmlformats.org/drawingml/2006/main">
               <a:ext uri="{FF2B5EF4-FFF2-40B4-BE49-F238E27FC236}">
-                <a16:creationId xmlns:a16="http://schemas.microsoft.com/office/drawing/2014/main" id="{8D02E0E9-9910-4496-9C70-13BAF4B459FF}"/>
+                <a16:creationId xmlns:a16="http://schemas.microsoft.com/office/drawing/2014/main" id="{38D27946-8674-41EC-9F2B-ED0103DFAEFE}"/>
               </a:ext>
             </a:extLst>
           </p:cNvPr>
@@ -2655,7 +2655,7 @@
           <p:cNvPr id="12" name="p10-in-2">
             <a:extLst xmlns:a="http://schemas.openxmlformats.org/drawingml/2006/main">
               <a:ext uri="{FF2B5EF4-FFF2-40B4-BE49-F238E27FC236}">
-                <a16:creationId xmlns:a16="http://schemas.microsoft.com/office/drawing/2014/main" id="{D6311A91-7444-4253-AA24-7138D3430E86}"/>
+                <a16:creationId xmlns:a16="http://schemas.microsoft.com/office/drawing/2014/main" id="{3A36CE35-3B62-43A1-B718-67E94311A6D4}"/>
               </a:ext>
             </a:extLst>
           </p:cNvPr>
@@ -2686,7 +2686,7 @@
           <p:cNvPr id="13" name="p10-in-2-text">
             <a:extLst xmlns:a="http://schemas.openxmlformats.org/drawingml/2006/main">
               <a:ext uri="{FF2B5EF4-FFF2-40B4-BE49-F238E27FC236}">
-                <a16:creationId xmlns:a16="http://schemas.microsoft.com/office/drawing/2014/main" id="{DED2BCD2-CA0D-407D-B708-75C9D1895B0F}"/>
+                <a16:creationId xmlns:a16="http://schemas.microsoft.com/office/drawing/2014/main" id="{58BEB0D9-A465-4DE1-9B04-41619B0375DE}"/>
               </a:ext>
             </a:extLst>
           </p:cNvPr>
@@ -2748,7 +2748,7 @@
           <p:cNvPr id="14" name="p10-path-2">
             <a:extLst xmlns:a="http://schemas.openxmlformats.org/drawingml/2006/main">
               <a:ext uri="{FF2B5EF4-FFF2-40B4-BE49-F238E27FC236}">
-                <a16:creationId xmlns:a16="http://schemas.microsoft.com/office/drawing/2014/main" id="{37DCECFE-B4F1-40F0-9A08-C371DE92C689}"/>
+                <a16:creationId xmlns:a16="http://schemas.microsoft.com/office/drawing/2014/main" id="{364F2671-2597-46B7-9B85-D519C37D323E}"/>
               </a:ext>
             </a:extLst>
           </p:cNvPr>
@@ -2779,7 +2779,7 @@
           <p:cNvPr id="15" name="p10-in-3">
             <a:extLst xmlns:a="http://schemas.openxmlformats.org/drawingml/2006/main">
               <a:ext uri="{FF2B5EF4-FFF2-40B4-BE49-F238E27FC236}">
-                <a16:creationId xmlns:a16="http://schemas.microsoft.com/office/drawing/2014/main" id="{928963F7-50EB-4AA3-98B6-4BE6100ADB50}"/>
+                <a16:creationId xmlns:a16="http://schemas.microsoft.com/office/drawing/2014/main" id="{61FC750D-B7BB-4070-B8BB-1F05F5A30C24}"/>
               </a:ext>
             </a:extLst>
           </p:cNvPr>
@@ -2810,7 +2810,7 @@
           <p:cNvPr id="16" name="p10-in-3-text">
             <a:extLst xmlns:a="http://schemas.openxmlformats.org/drawingml/2006/main">
               <a:ext uri="{FF2B5EF4-FFF2-40B4-BE49-F238E27FC236}">
-                <a16:creationId xmlns:a16="http://schemas.microsoft.com/office/drawing/2014/main" id="{0D63DA5A-6D1E-4B47-9575-688C90ABE661}"/>
+                <a16:creationId xmlns:a16="http://schemas.microsoft.com/office/drawing/2014/main" id="{5C325215-C1F7-4E2A-B261-B8F46DD04047}"/>
               </a:ext>
             </a:extLst>
           </p:cNvPr>
@@ -2872,7 +2872,7 @@
           <p:cNvPr id="17" name="p10-path-3">
             <a:extLst xmlns:a="http://schemas.openxmlformats.org/drawingml/2006/main">
               <a:ext uri="{FF2B5EF4-FFF2-40B4-BE49-F238E27FC236}">
-                <a16:creationId xmlns:a16="http://schemas.microsoft.com/office/drawing/2014/main" id="{C16B9A2A-8491-4FFF-ABB5-EF5B1815A679}"/>
+                <a16:creationId xmlns:a16="http://schemas.microsoft.com/office/drawing/2014/main" id="{16812545-B76A-4F3D-B3DE-322864AB3402}"/>
               </a:ext>
             </a:extLst>
           </p:cNvPr>
@@ -2903,7 +2903,7 @@
           <p:cNvPr id="18" name="p10-output-bg">
             <a:extLst xmlns:a="http://schemas.openxmlformats.org/drawingml/2006/main">
               <a:ext uri="{FF2B5EF4-FFF2-40B4-BE49-F238E27FC236}">
-                <a16:creationId xmlns:a16="http://schemas.microsoft.com/office/drawing/2014/main" id="{90325F26-E1BE-4EAC-8134-C646F18CF995}"/>
+                <a16:creationId xmlns:a16="http://schemas.microsoft.com/office/drawing/2014/main" id="{B8E37854-AF83-44CF-9CD6-3A57D0D87554}"/>
               </a:ext>
             </a:extLst>
           </p:cNvPr>
@@ -2934,7 +2934,7 @@
           <p:cNvPr id="19" name="p10-output-title">
             <a:extLst xmlns:a="http://schemas.openxmlformats.org/drawingml/2006/main">
               <a:ext uri="{FF2B5EF4-FFF2-40B4-BE49-F238E27FC236}">
-                <a16:creationId xmlns:a16="http://schemas.microsoft.com/office/drawing/2014/main" id="{83C78E9F-3615-4036-A70C-8A8199D38DD0}"/>
+                <a16:creationId xmlns:a16="http://schemas.microsoft.com/office/drawing/2014/main" id="{E23E03D7-67B3-49FE-9016-2250DBF9EECD}"/>
               </a:ext>
             </a:extLst>
           </p:cNvPr>
@@ -2996,7 +2996,7 @@
           <p:cNvPr id="20" name="p10-output-body">
             <a:extLst xmlns:a="http://schemas.openxmlformats.org/drawingml/2006/main">
               <a:ext uri="{FF2B5EF4-FFF2-40B4-BE49-F238E27FC236}">
-                <a16:creationId xmlns:a16="http://schemas.microsoft.com/office/drawing/2014/main" id="{64EEA906-46C2-468D-9912-52EE5C9A7F1F}"/>
+                <a16:creationId xmlns:a16="http://schemas.microsoft.com/office/drawing/2014/main" id="{C4ED85B0-E770-4FA1-A819-E483068DE7C2}"/>
               </a:ext>
             </a:extLst>
           </p:cNvPr>
@@ -3058,7 +3058,7 @@
           <p:cNvPr id="21" name="p10-note">
             <a:extLst xmlns:a="http://schemas.openxmlformats.org/drawingml/2006/main">
               <a:ext uri="{FF2B5EF4-FFF2-40B4-BE49-F238E27FC236}">
-                <a16:creationId xmlns:a16="http://schemas.microsoft.com/office/drawing/2014/main" id="{DEA4311E-009C-43D2-B561-8D8E33058DF3}"/>
+                <a16:creationId xmlns:a16="http://schemas.microsoft.com/office/drawing/2014/main" id="{C9A5D041-4AF1-40E0-A05C-89FBFB056275}"/>
               </a:ext>
             </a:extLst>
           </p:cNvPr>
@@ -3118,7 +3118,7 @@
     </p:spTree>
     <p:extLst>
       <p:ext uri="{BB962C8B-B14F-4D97-AF65-F5344CB8AC3E}">
-        <p14:creationId xmlns:p14="http://schemas.microsoft.com/office/powerpoint/2010/main" val="1010979457"/>
+        <p14:creationId xmlns:p14="http://schemas.microsoft.com/office/powerpoint/2010/main" val="698036159"/>
       </p:ext>
     </p:extLst>
   </p:cSld>
@@ -3146,10 +3146,10 @@
       </p:grpSpPr>
       <p:sp>
         <p:nvSpPr>
-          <p:cNvPr id="8" name="p11-accent">
-            <a:extLst xmlns:a="http://schemas.openxmlformats.org/drawingml/2006/main">
-              <a:ext uri="{FF2B5EF4-FFF2-40B4-BE49-F238E27FC236}">
-                <a16:creationId xmlns:a16="http://schemas.microsoft.com/office/drawing/2014/main" id="{D49B4020-56A9-4FBB-BC2B-9E7570DE49BF}"/>
+          <p:cNvPr id="9" name="p11-accent">
+            <a:extLst xmlns:a="http://schemas.openxmlformats.org/drawingml/2006/main">
+              <a:ext uri="{FF2B5EF4-FFF2-40B4-BE49-F238E27FC236}">
+                <a16:creationId xmlns:a16="http://schemas.microsoft.com/office/drawing/2014/main" id="{DF837821-73EF-4BA5-99F1-1E79B82D0CBB}"/>
               </a:ext>
             </a:extLst>
           </p:cNvPr>
@@ -3180,7 +3180,7 @@
           <p:cNvPr id="2" name="p11-kicker">
             <a:extLst xmlns:a="http://schemas.openxmlformats.org/drawingml/2006/main">
               <a:ext uri="{FF2B5EF4-FFF2-40B4-BE49-F238E27FC236}">
-                <a16:creationId xmlns:a16="http://schemas.microsoft.com/office/drawing/2014/main" id="{0CE0C1CE-92E0-4E4C-95EA-00C36C24E4DF}"/>
+                <a16:creationId xmlns:a16="http://schemas.microsoft.com/office/drawing/2014/main" id="{A91448B7-2D53-4F00-8F2E-A179A43A593E}"/>
               </a:ext>
             </a:extLst>
           </p:cNvPr>
@@ -3242,7 +3242,7 @@
           <p:cNvPr id="3" name="p11-title">
             <a:extLst xmlns:a="http://schemas.openxmlformats.org/drawingml/2006/main">
               <a:ext uri="{FF2B5EF4-FFF2-40B4-BE49-F238E27FC236}">
-                <a16:creationId xmlns:a16="http://schemas.microsoft.com/office/drawing/2014/main" id="{ECE9641F-41DD-4E8D-AB89-B2FAA1C9351D}"/>
+                <a16:creationId xmlns:a16="http://schemas.microsoft.com/office/drawing/2014/main" id="{86C27BEA-EFB9-4CFF-AB32-62794AF115C8}"/>
               </a:ext>
             </a:extLst>
           </p:cNvPr>
@@ -3304,7 +3304,7 @@
           <p:cNvPr id="4" name="p11-quote">
             <a:extLst xmlns:a="http://schemas.openxmlformats.org/drawingml/2006/main">
               <a:ext uri="{FF2B5EF4-FFF2-40B4-BE49-F238E27FC236}">
-                <a16:creationId xmlns:a16="http://schemas.microsoft.com/office/drawing/2014/main" id="{8C10A437-A4A3-493A-A2AB-7FAFD9A67190}"/>
+                <a16:creationId xmlns:a16="http://schemas.microsoft.com/office/drawing/2014/main" id="{77FE5041-F6F5-419B-97DF-48983D8B8968}"/>
               </a:ext>
             </a:extLst>
           </p:cNvPr>
@@ -3366,7 +3366,7 @@
           <p:cNvPr id="5" name="p11-divider">
             <a:extLst xmlns:a="http://schemas.openxmlformats.org/drawingml/2006/main">
               <a:ext uri="{FF2B5EF4-FFF2-40B4-BE49-F238E27FC236}">
-                <a16:creationId xmlns:a16="http://schemas.microsoft.com/office/drawing/2014/main" id="{B53586C4-98CB-4C07-A5FC-C7A993F94C68}"/>
+                <a16:creationId xmlns:a16="http://schemas.microsoft.com/office/drawing/2014/main" id="{59756E44-99CD-4A41-8A70-67B372A3DCBB}"/>
               </a:ext>
             </a:extLst>
           </p:cNvPr>
@@ -3397,7 +3397,7 @@
           <p:cNvPr id="6" name="p11-last">
             <a:extLst xmlns:a="http://schemas.openxmlformats.org/drawingml/2006/main">
               <a:ext uri="{FF2B5EF4-FFF2-40B4-BE49-F238E27FC236}">
-                <a16:creationId xmlns:a16="http://schemas.microsoft.com/office/drawing/2014/main" id="{CC8608AA-1E5E-49B1-9B52-5B578CA9E36F}"/>
+                <a16:creationId xmlns:a16="http://schemas.microsoft.com/office/drawing/2014/main" id="{06B353ED-0B6E-4F64-8307-BED8A01AA5C2}"/>
               </a:ext>
             </a:extLst>
           </p:cNvPr>
@@ -3456,10 +3456,72 @@
       </p:sp>
       <p:sp>
         <p:nvSpPr>
-          <p:cNvPr id="7" name="p11-page">
-            <a:extLst xmlns:a="http://schemas.openxmlformats.org/drawingml/2006/main">
-              <a:ext uri="{FF2B5EF4-FFF2-40B4-BE49-F238E27FC236}">
-                <a16:creationId xmlns:a16="http://schemas.microsoft.com/office/drawing/2014/main" id="{CC3C6BCD-4AD1-44D1-A5D7-8269C8968DE9}"/>
+          <p:cNvPr id="7" name="p11-opportunity">
+            <a:extLst xmlns:a="http://schemas.openxmlformats.org/drawingml/2006/main">
+              <a:ext uri="{FF2B5EF4-FFF2-40B4-BE49-F238E27FC236}">
+                <a16:creationId xmlns:a16="http://schemas.microsoft.com/office/drawing/2014/main" id="{4D0B5D29-B8C4-43A6-94E8-885B93AFBE77}"/>
+              </a:ext>
+            </a:extLst>
+          </p:cNvPr>
+          <p:cNvSpPr>
+            <a:spLocks xmlns:a="http://schemas.openxmlformats.org/drawingml/2006/main" noGrp="1"/>
+          </p:cNvSpPr>
+          <p:nvPr/>
+        </p:nvSpPr>
+        <p:spPr>
+          <a:xfrm xmlns:a="http://schemas.openxmlformats.org/drawingml/2006/main">
+            <a:off x="876300" y="4953000"/>
+            <a:ext cx="8572500" cy="285750"/>
+          </a:xfrm>
+          <a:prstGeom xmlns:a="http://schemas.openxmlformats.org/drawingml/2006/main" prst="rect">
+            <a:avLst/>
+          </a:prstGeom>
+          <a:noFill xmlns:a="http://schemas.openxmlformats.org/drawingml/2006/main"/>
+          <a:ln xmlns:a="http://schemas.openxmlformats.org/drawingml/2006/main" w="0">
+            <a:noFill/>
+            <a:prstDash val="solid"/>
+          </a:ln>
+        </p:spPr>
+        <p:txBody>
+          <a:bodyPr xmlns:a="http://schemas.openxmlformats.org/drawingml/2006/main" wrap="square" anchor="t">
+            <a:noAutofit/>
+          </a:bodyPr>
+          <a:lstStyle xmlns:a="http://schemas.openxmlformats.org/drawingml/2006/main"/>
+          <a:p xmlns:a="http://schemas.openxmlformats.org/drawingml/2006/main">
+            <a:pPr algn="l">
+              <a:lnSpc>
+                <a:spcPct val="140000"/>
+              </a:lnSpc>
+              <a:buNone/>
+              <a:defRPr sz="1200" b="0">
+                <a:solidFill>
+                  <a:srgbClr val="707780"/>
+                </a:solidFill>
+                <a:latin typeface="Microsoft YaHei"/>
+                <a:ea typeface="Microsoft YaHei"/>
+                <a:cs typeface="Microsoft YaHei"/>
+              </a:defRPr>
+            </a:pPr>
+            <a:r>
+              <a:rPr sz="1200" b="0">
+                <a:solidFill>
+                  <a:srgbClr val="707780"/>
+                </a:solidFill>
+                <a:latin typeface="Microsoft YaHei"/>
+                <a:ea typeface="Microsoft YaHei"/>
+                <a:cs typeface="Microsoft YaHei"/>
+              </a:rPr>
+              <a:t>也有机会形成一门真正的生意。</a:t>
+            </a:r>
+          </a:p>
+        </p:txBody>
+      </p:sp>
+      <p:sp>
+        <p:nvSpPr>
+          <p:cNvPr id="8" name="p11-page">
+            <a:extLst xmlns:a="http://schemas.openxmlformats.org/drawingml/2006/main">
+              <a:ext uri="{FF2B5EF4-FFF2-40B4-BE49-F238E27FC236}">
+                <a16:creationId xmlns:a16="http://schemas.microsoft.com/office/drawing/2014/main" id="{B596098B-CB1A-4152-95D2-8A737C93E1CE}"/>
               </a:ext>
             </a:extLst>
           </p:cNvPr>
@@ -3519,7 +3581,7 @@
     </p:spTree>
     <p:extLst>
       <p:ext uri="{BB962C8B-B14F-4D97-AF65-F5344CB8AC3E}">
-        <p14:creationId xmlns:p14="http://schemas.microsoft.com/office/powerpoint/2010/main" val="764207202"/>
+        <p14:creationId xmlns:p14="http://schemas.microsoft.com/office/powerpoint/2010/main" val="231802945"/>
       </p:ext>
     </p:extLst>
   </p:cSld>
@@ -3550,7 +3612,7 @@
           <p:cNvPr id="16" name="p2-eyebrow">
             <a:extLst xmlns:a="http://schemas.openxmlformats.org/drawingml/2006/main">
               <a:ext uri="{FF2B5EF4-FFF2-40B4-BE49-F238E27FC236}">
-                <a16:creationId xmlns:a16="http://schemas.microsoft.com/office/drawing/2014/main" id="{16F1FB2F-1364-4A0E-A7FA-A095689DA87D}"/>
+                <a16:creationId xmlns:a16="http://schemas.microsoft.com/office/drawing/2014/main" id="{91D00527-22D6-4EC6-AAC1-FCA5E99578DD}"/>
               </a:ext>
             </a:extLst>
           </p:cNvPr>
@@ -3584,7 +3646,7 @@
                 <a:spcPct val="140000"/>
               </a:lnSpc>
               <a:buNone/>
-              <a:defRPr sz="900" b="1">
+              <a:defRPr sz="900" b="0">
                 <a:solidFill>
                   <a:srgbClr val="315F91"/>
                 </a:solidFill>
@@ -3594,7 +3656,7 @@
               </a:defRPr>
             </a:pPr>
             <a:r>
-              <a:rPr sz="900" b="1">
+              <a:rPr sz="900" b="0">
                 <a:solidFill>
                   <a:srgbClr val="315F91"/>
                 </a:solidFill>
@@ -3612,7 +3674,7 @@
           <p:cNvPr id="2" name="p2-title">
             <a:extLst xmlns:a="http://schemas.openxmlformats.org/drawingml/2006/main">
               <a:ext uri="{FF2B5EF4-FFF2-40B4-BE49-F238E27FC236}">
-                <a16:creationId xmlns:a16="http://schemas.microsoft.com/office/drawing/2014/main" id="{BA0871F0-06B7-4008-8C01-F4367C5A68EC}"/>
+                <a16:creationId xmlns:a16="http://schemas.microsoft.com/office/drawing/2014/main" id="{99985816-4AA7-46D9-A068-A8A1E5AF30A2}"/>
               </a:ext>
             </a:extLst>
           </p:cNvPr>
@@ -3674,7 +3736,7 @@
           <p:cNvPr id="3" name="p2-divider">
             <a:extLst xmlns:a="http://schemas.openxmlformats.org/drawingml/2006/main">
               <a:ext uri="{FF2B5EF4-FFF2-40B4-BE49-F238E27FC236}">
-                <a16:creationId xmlns:a16="http://schemas.microsoft.com/office/drawing/2014/main" id="{88825506-1B48-4C14-8AD0-0E2FB44F043B}"/>
+                <a16:creationId xmlns:a16="http://schemas.microsoft.com/office/drawing/2014/main" id="{85CA2643-0C67-4A5F-BD6D-B27469E31F40}"/>
               </a:ext>
             </a:extLst>
           </p:cNvPr>
@@ -3705,7 +3767,7 @@
           <p:cNvPr id="4" name="p2-footer">
             <a:extLst xmlns:a="http://schemas.openxmlformats.org/drawingml/2006/main">
               <a:ext uri="{FF2B5EF4-FFF2-40B4-BE49-F238E27FC236}">
-                <a16:creationId xmlns:a16="http://schemas.microsoft.com/office/drawing/2014/main" id="{B90F4597-89E5-4592-A20E-46E4344581BB}"/>
+                <a16:creationId xmlns:a16="http://schemas.microsoft.com/office/drawing/2014/main" id="{4AADEBDE-0D0A-4AC6-8564-9DDF3A88FA52}"/>
               </a:ext>
             </a:extLst>
           </p:cNvPr>
@@ -3767,7 +3829,7 @@
           <p:cNvPr id="5" name="p2-lead">
             <a:extLst xmlns:a="http://schemas.openxmlformats.org/drawingml/2006/main">
               <a:ext uri="{FF2B5EF4-FFF2-40B4-BE49-F238E27FC236}">
-                <a16:creationId xmlns:a16="http://schemas.microsoft.com/office/drawing/2014/main" id="{BE0EC3FA-24A6-4D2C-8810-46E7A32B8508}"/>
+                <a16:creationId xmlns:a16="http://schemas.microsoft.com/office/drawing/2014/main" id="{7BA8076B-1AC2-4FAF-BA9D-06A3D24FE6C0}"/>
               </a:ext>
             </a:extLst>
           </p:cNvPr>
@@ -3829,7 +3891,7 @@
           <p:cNvPr id="6" name="p2-g1-label">
             <a:extLst xmlns:a="http://schemas.openxmlformats.org/drawingml/2006/main">
               <a:ext uri="{FF2B5EF4-FFF2-40B4-BE49-F238E27FC236}">
-                <a16:creationId xmlns:a16="http://schemas.microsoft.com/office/drawing/2014/main" id="{68EEAFC9-371A-48B1-8D63-B7FAD5EB4C5C}"/>
+                <a16:creationId xmlns:a16="http://schemas.microsoft.com/office/drawing/2014/main" id="{C42A6AE4-9703-4172-BD0B-8DE46ED0225D}"/>
               </a:ext>
             </a:extLst>
           </p:cNvPr>
@@ -3891,7 +3953,7 @@
           <p:cNvPr id="7" name="p2-g1-body">
             <a:extLst xmlns:a="http://schemas.openxmlformats.org/drawingml/2006/main">
               <a:ext uri="{FF2B5EF4-FFF2-40B4-BE49-F238E27FC236}">
-                <a16:creationId xmlns:a16="http://schemas.microsoft.com/office/drawing/2014/main" id="{D71C2B19-00B3-463F-94F8-8E87E8434F83}"/>
+                <a16:creationId xmlns:a16="http://schemas.microsoft.com/office/drawing/2014/main" id="{AA012E2F-F53C-4AED-BBC6-87CAA0E36E06}"/>
               </a:ext>
             </a:extLst>
           </p:cNvPr>
@@ -3953,7 +4015,7 @@
           <p:cNvPr id="8" name="p2-g2-label">
             <a:extLst xmlns:a="http://schemas.openxmlformats.org/drawingml/2006/main">
               <a:ext uri="{FF2B5EF4-FFF2-40B4-BE49-F238E27FC236}">
-                <a16:creationId xmlns:a16="http://schemas.microsoft.com/office/drawing/2014/main" id="{D6C76641-8EB0-483C-9FEC-8380FC9E534A}"/>
+                <a16:creationId xmlns:a16="http://schemas.microsoft.com/office/drawing/2014/main" id="{BA1B1AF8-5E43-4B37-AEF5-2E1D2E31D5D5}"/>
               </a:ext>
             </a:extLst>
           </p:cNvPr>
@@ -4015,7 +4077,7 @@
           <p:cNvPr id="9" name="p2-g2-body">
             <a:extLst xmlns:a="http://schemas.openxmlformats.org/drawingml/2006/main">
               <a:ext uri="{FF2B5EF4-FFF2-40B4-BE49-F238E27FC236}">
-                <a16:creationId xmlns:a16="http://schemas.microsoft.com/office/drawing/2014/main" id="{31B8DED8-0E96-4B37-8CD2-07E234ACD169}"/>
+                <a16:creationId xmlns:a16="http://schemas.microsoft.com/office/drawing/2014/main" id="{1BD41B72-E18E-4BB4-8CD6-66C247FC3928}"/>
               </a:ext>
             </a:extLst>
           </p:cNvPr>
@@ -4077,7 +4139,7 @@
           <p:cNvPr id="10" name="p2-g3-label">
             <a:extLst xmlns:a="http://schemas.openxmlformats.org/drawingml/2006/main">
               <a:ext uri="{FF2B5EF4-FFF2-40B4-BE49-F238E27FC236}">
-                <a16:creationId xmlns:a16="http://schemas.microsoft.com/office/drawing/2014/main" id="{515A7C1B-3CC9-46DE-8736-CE4178995863}"/>
+                <a16:creationId xmlns:a16="http://schemas.microsoft.com/office/drawing/2014/main" id="{F93303BA-5B7B-43DA-A8B8-DFBB84DA4381}"/>
               </a:ext>
             </a:extLst>
           </p:cNvPr>
@@ -4139,7 +4201,7 @@
           <p:cNvPr id="11" name="p2-g3-body">
             <a:extLst xmlns:a="http://schemas.openxmlformats.org/drawingml/2006/main">
               <a:ext uri="{FF2B5EF4-FFF2-40B4-BE49-F238E27FC236}">
-                <a16:creationId xmlns:a16="http://schemas.microsoft.com/office/drawing/2014/main" id="{C1DC1FDD-12DC-4849-9124-C091B48DEA29}"/>
+                <a16:creationId xmlns:a16="http://schemas.microsoft.com/office/drawing/2014/main" id="{5C9A59BC-4EBE-4F2F-B6FE-44D19C4ACE74}"/>
               </a:ext>
             </a:extLst>
           </p:cNvPr>
@@ -4201,7 +4263,7 @@
           <p:cNvPr id="12" name="p2-analysis-surface">
             <a:extLst xmlns:a="http://schemas.openxmlformats.org/drawingml/2006/main">
               <a:ext uri="{FF2B5EF4-FFF2-40B4-BE49-F238E27FC236}">
-                <a16:creationId xmlns:a16="http://schemas.microsoft.com/office/drawing/2014/main" id="{10B4D059-7B07-4B23-ADB4-9C4653B81EC2}"/>
+                <a16:creationId xmlns:a16="http://schemas.microsoft.com/office/drawing/2014/main" id="{88F9302B-2B6B-426B-8835-718CBEC53B48}"/>
               </a:ext>
             </a:extLst>
           </p:cNvPr>
@@ -4232,7 +4294,7 @@
           <p:cNvPr id="13" name="p2-side-title">
             <a:extLst xmlns:a="http://schemas.openxmlformats.org/drawingml/2006/main">
               <a:ext uri="{FF2B5EF4-FFF2-40B4-BE49-F238E27FC236}">
-                <a16:creationId xmlns:a16="http://schemas.microsoft.com/office/drawing/2014/main" id="{0EFA8A70-DDEB-4E65-8A9E-F2A803F1FEDF}"/>
+                <a16:creationId xmlns:a16="http://schemas.microsoft.com/office/drawing/2014/main" id="{D8B927CA-A922-401A-96BF-675BB1792FF0}"/>
               </a:ext>
             </a:extLst>
           </p:cNvPr>
@@ -4294,7 +4356,7 @@
           <p:cNvPr id="14" name="p2-side-body">
             <a:extLst xmlns:a="http://schemas.openxmlformats.org/drawingml/2006/main">
               <a:ext uri="{FF2B5EF4-FFF2-40B4-BE49-F238E27FC236}">
-                <a16:creationId xmlns:a16="http://schemas.microsoft.com/office/drawing/2014/main" id="{3B23215F-4CA1-4363-8171-FD212BA35BF4}"/>
+                <a16:creationId xmlns:a16="http://schemas.microsoft.com/office/drawing/2014/main" id="{0665C3EB-B64B-4427-B3DB-5D9B15A4177B}"/>
               </a:ext>
             </a:extLst>
           </p:cNvPr>
@@ -4383,7 +4445,7 @@
           <p:cNvPr id="15" name="p2-side-note">
             <a:extLst xmlns:a="http://schemas.openxmlformats.org/drawingml/2006/main">
               <a:ext uri="{FF2B5EF4-FFF2-40B4-BE49-F238E27FC236}">
-                <a16:creationId xmlns:a16="http://schemas.microsoft.com/office/drawing/2014/main" id="{CEE48F8F-A723-4E6D-97F6-BD742BEEEFA7}"/>
+                <a16:creationId xmlns:a16="http://schemas.microsoft.com/office/drawing/2014/main" id="{ED9DF428-16B8-47FF-A62C-52992E83FD41}"/>
               </a:ext>
             </a:extLst>
           </p:cNvPr>
@@ -4443,7 +4505,7 @@
     </p:spTree>
     <p:extLst>
       <p:ext uri="{BB962C8B-B14F-4D97-AF65-F5344CB8AC3E}">
-        <p14:creationId xmlns:p14="http://schemas.microsoft.com/office/powerpoint/2010/main" val="1516987552"/>
+        <p14:creationId xmlns:p14="http://schemas.microsoft.com/office/powerpoint/2010/main" val="118166661"/>
       </p:ext>
     </p:extLst>
   </p:cSld>
@@ -4474,7 +4536,7 @@
           <p:cNvPr id="17" name="p3-eyebrow">
             <a:extLst xmlns:a="http://schemas.openxmlformats.org/drawingml/2006/main">
               <a:ext uri="{FF2B5EF4-FFF2-40B4-BE49-F238E27FC236}">
-                <a16:creationId xmlns:a16="http://schemas.microsoft.com/office/drawing/2014/main" id="{5CDFC71D-826F-40F4-BF99-A72A9566BB63}"/>
+                <a16:creationId xmlns:a16="http://schemas.microsoft.com/office/drawing/2014/main" id="{757A2921-F398-4359-B393-FEC4A09433C7}"/>
               </a:ext>
             </a:extLst>
           </p:cNvPr>
@@ -4508,7 +4570,7 @@
                 <a:spcPct val="140000"/>
               </a:lnSpc>
               <a:buNone/>
-              <a:defRPr sz="900" b="1">
+              <a:defRPr sz="900" b="0">
                 <a:solidFill>
                   <a:srgbClr val="315F91"/>
                 </a:solidFill>
@@ -4518,7 +4580,7 @@
               </a:defRPr>
             </a:pPr>
             <a:r>
-              <a:rPr sz="900" b="1">
+              <a:rPr sz="900" b="0">
                 <a:solidFill>
                   <a:srgbClr val="315F91"/>
                 </a:solidFill>
@@ -4536,7 +4598,7 @@
           <p:cNvPr id="2" name="p3-title">
             <a:extLst xmlns:a="http://schemas.openxmlformats.org/drawingml/2006/main">
               <a:ext uri="{FF2B5EF4-FFF2-40B4-BE49-F238E27FC236}">
-                <a16:creationId xmlns:a16="http://schemas.microsoft.com/office/drawing/2014/main" id="{30AAA836-E32E-4760-8D4E-85B7EA17A01C}"/>
+                <a16:creationId xmlns:a16="http://schemas.microsoft.com/office/drawing/2014/main" id="{F5773CBD-6501-4724-B021-0B5B7961FC8B}"/>
               </a:ext>
             </a:extLst>
           </p:cNvPr>
@@ -4598,7 +4660,7 @@
           <p:cNvPr id="3" name="p3-divider">
             <a:extLst xmlns:a="http://schemas.openxmlformats.org/drawingml/2006/main">
               <a:ext uri="{FF2B5EF4-FFF2-40B4-BE49-F238E27FC236}">
-                <a16:creationId xmlns:a16="http://schemas.microsoft.com/office/drawing/2014/main" id="{6D68AE00-6F7A-4E1B-ACC9-FD37AAD17E60}"/>
+                <a16:creationId xmlns:a16="http://schemas.microsoft.com/office/drawing/2014/main" id="{6E1C84B2-2D89-4116-8A23-A52BD2AD4EE8}"/>
               </a:ext>
             </a:extLst>
           </p:cNvPr>
@@ -4629,7 +4691,7 @@
           <p:cNvPr id="4" name="p3-footer">
             <a:extLst xmlns:a="http://schemas.openxmlformats.org/drawingml/2006/main">
               <a:ext uri="{FF2B5EF4-FFF2-40B4-BE49-F238E27FC236}">
-                <a16:creationId xmlns:a16="http://schemas.microsoft.com/office/drawing/2014/main" id="{32A59D0D-8657-4144-94A0-E30046DE1181}"/>
+                <a16:creationId xmlns:a16="http://schemas.microsoft.com/office/drawing/2014/main" id="{071EB223-E5E9-4660-8ED4-659AE5943B9D}"/>
               </a:ext>
             </a:extLst>
           </p:cNvPr>
@@ -4691,7 +4753,7 @@
           <p:cNvPr id="5" name="p3-intro">
             <a:extLst xmlns:a="http://schemas.openxmlformats.org/drawingml/2006/main">
               <a:ext uri="{FF2B5EF4-FFF2-40B4-BE49-F238E27FC236}">
-                <a16:creationId xmlns:a16="http://schemas.microsoft.com/office/drawing/2014/main" id="{4F749F59-9389-491D-B84A-BE7BFD515022}"/>
+                <a16:creationId xmlns:a16="http://schemas.microsoft.com/office/drawing/2014/main" id="{76014DCC-35BB-478C-85E4-82A4B5B8880E}"/>
               </a:ext>
             </a:extLst>
           </p:cNvPr>
@@ -4753,7 +4815,7 @@
           <p:cNvPr id="6" name="p3-left-label">
             <a:extLst xmlns:a="http://schemas.openxmlformats.org/drawingml/2006/main">
               <a:ext uri="{FF2B5EF4-FFF2-40B4-BE49-F238E27FC236}">
-                <a16:creationId xmlns:a16="http://schemas.microsoft.com/office/drawing/2014/main" id="{4E46F418-3B93-4C78-A560-8E8763F492A9}"/>
+                <a16:creationId xmlns:a16="http://schemas.microsoft.com/office/drawing/2014/main" id="{A6519B1F-C5A8-4297-8899-AECAE30C6250}"/>
               </a:ext>
             </a:extLst>
           </p:cNvPr>
@@ -4815,7 +4877,7 @@
           <p:cNvPr id="7" name="p3-axis">
             <a:extLst xmlns:a="http://schemas.openxmlformats.org/drawingml/2006/main">
               <a:ext uri="{FF2B5EF4-FFF2-40B4-BE49-F238E27FC236}">
-                <a16:creationId xmlns:a16="http://schemas.microsoft.com/office/drawing/2014/main" id="{69BE1FFE-8662-4966-9F01-286289ADAF7D}"/>
+                <a16:creationId xmlns:a16="http://schemas.microsoft.com/office/drawing/2014/main" id="{9075EDBC-4153-42D2-A51A-D0A3D1774FBB}"/>
               </a:ext>
             </a:extLst>
           </p:cNvPr>
@@ -4846,7 +4908,7 @@
           <p:cNvPr id="8" name="p3-target-band">
             <a:extLst xmlns:a="http://schemas.openxmlformats.org/drawingml/2006/main">
               <a:ext uri="{FF2B5EF4-FFF2-40B4-BE49-F238E27FC236}">
-                <a16:creationId xmlns:a16="http://schemas.microsoft.com/office/drawing/2014/main" id="{D35D442F-7D97-4467-BF26-A0EA6C59A0C2}"/>
+                <a16:creationId xmlns:a16="http://schemas.microsoft.com/office/drawing/2014/main" id="{B5B3F26D-52E3-42C2-975F-C1B4A9E9FD8B}"/>
               </a:ext>
             </a:extLst>
           </p:cNvPr>
@@ -4877,7 +4939,7 @@
           <p:cNvPr id="9" name="p3-low">
             <a:extLst xmlns:a="http://schemas.openxmlformats.org/drawingml/2006/main">
               <a:ext uri="{FF2B5EF4-FFF2-40B4-BE49-F238E27FC236}">
-                <a16:creationId xmlns:a16="http://schemas.microsoft.com/office/drawing/2014/main" id="{76DC3B13-F504-4A94-AA9B-4FCBBAEBC622}"/>
+                <a16:creationId xmlns:a16="http://schemas.microsoft.com/office/drawing/2014/main" id="{C45CD220-C297-4A1A-976B-14A76EC85F1C}"/>
               </a:ext>
             </a:extLst>
           </p:cNvPr>
@@ -4939,7 +5001,7 @@
           <p:cNvPr id="10" name="p3-target">
             <a:extLst xmlns:a="http://schemas.openxmlformats.org/drawingml/2006/main">
               <a:ext uri="{FF2B5EF4-FFF2-40B4-BE49-F238E27FC236}">
-                <a16:creationId xmlns:a16="http://schemas.microsoft.com/office/drawing/2014/main" id="{CBF81A1E-BB60-4BF0-B89C-94CFE40F235B}"/>
+                <a16:creationId xmlns:a16="http://schemas.microsoft.com/office/drawing/2014/main" id="{656AFB83-85B8-4DD4-B82A-E5D12520F399}"/>
               </a:ext>
             </a:extLst>
           </p:cNvPr>
@@ -5001,7 +5063,7 @@
           <p:cNvPr id="11" name="p3-high">
             <a:extLst xmlns:a="http://schemas.openxmlformats.org/drawingml/2006/main">
               <a:ext uri="{FF2B5EF4-FFF2-40B4-BE49-F238E27FC236}">
-                <a16:creationId xmlns:a16="http://schemas.microsoft.com/office/drawing/2014/main" id="{2C6E1AC4-1EA8-4506-972D-54BF4D13291B}"/>
+                <a16:creationId xmlns:a16="http://schemas.microsoft.com/office/drawing/2014/main" id="{0A60C1DD-1721-4992-8CDA-85482CDF5725}"/>
               </a:ext>
             </a:extLst>
           </p:cNvPr>
@@ -5063,7 +5125,7 @@
           <p:cNvPr id="12" name="p3-band-note">
             <a:extLst xmlns:a="http://schemas.openxmlformats.org/drawingml/2006/main">
               <a:ext uri="{FF2B5EF4-FFF2-40B4-BE49-F238E27FC236}">
-                <a16:creationId xmlns:a16="http://schemas.microsoft.com/office/drawing/2014/main" id="{AF942EC7-F823-40D6-94E3-2E0BB96C9B16}"/>
+                <a16:creationId xmlns:a16="http://schemas.microsoft.com/office/drawing/2014/main" id="{6BD9153D-A1E5-4AC9-BE64-F9223DBE89CD}"/>
               </a:ext>
             </a:extLst>
           </p:cNvPr>
@@ -5118,6 +5180,33 @@
               <a:t>不能乱、不能丑、不能掉价、不能生成完以后无法修改。</a:t>
             </a:r>
           </a:p>
+          <a:p xmlns:a="http://schemas.openxmlformats.org/drawingml/2006/main">
+            <a:pPr algn="l">
+              <a:lnSpc>
+                <a:spcPct val="140000"/>
+              </a:lnSpc>
+              <a:buNone/>
+              <a:defRPr sz="1350" b="0">
+                <a:solidFill>
+                  <a:srgbClr val="252B33"/>
+                </a:solidFill>
+                <a:latin typeface="Microsoft YaHei"/>
+                <a:ea typeface="Microsoft YaHei"/>
+                <a:cs typeface="Microsoft YaHei"/>
+              </a:defRPr>
+            </a:pPr>
+            <a:r>
+              <a:rPr sz="1350" b="0">
+                <a:solidFill>
+                  <a:srgbClr val="252B33"/>
+                </a:solidFill>
+                <a:latin typeface="Microsoft YaHei"/>
+                <a:ea typeface="Microsoft YaHei"/>
+                <a:cs typeface="Microsoft YaHei"/>
+              </a:rPr>
+              <a:t>主要场景：学校、科研院所、事业单位、央国企和普通企业。</a:t>
+            </a:r>
+          </a:p>
         </p:txBody>
       </p:sp>
       <p:sp>
@@ -5125,7 +5214,7 @@
           <p:cNvPr id="13" name="p3-formula-surface">
             <a:extLst xmlns:a="http://schemas.openxmlformats.org/drawingml/2006/main">
               <a:ext uri="{FF2B5EF4-FFF2-40B4-BE49-F238E27FC236}">
-                <a16:creationId xmlns:a16="http://schemas.microsoft.com/office/drawing/2014/main" id="{022ED6DE-2A11-415F-B3BE-C7AD01BEC816}"/>
+                <a16:creationId xmlns:a16="http://schemas.microsoft.com/office/drawing/2014/main" id="{0E146264-CDA7-43DC-BA8D-2A8F8AC27273}"/>
               </a:ext>
             </a:extLst>
           </p:cNvPr>
@@ -5156,7 +5245,7 @@
           <p:cNvPr id="14" name="p3-formula-label">
             <a:extLst xmlns:a="http://schemas.openxmlformats.org/drawingml/2006/main">
               <a:ext uri="{FF2B5EF4-FFF2-40B4-BE49-F238E27FC236}">
-                <a16:creationId xmlns:a16="http://schemas.microsoft.com/office/drawing/2014/main" id="{20AAAB4A-620C-4CE4-9C84-93D69EDFA224}"/>
+                <a16:creationId xmlns:a16="http://schemas.microsoft.com/office/drawing/2014/main" id="{6E2215C7-7265-45CD-B169-E3CE27786319}"/>
               </a:ext>
             </a:extLst>
           </p:cNvPr>
@@ -5218,7 +5307,7 @@
           <p:cNvPr id="15" name="p3-formula">
             <a:extLst xmlns:a="http://schemas.openxmlformats.org/drawingml/2006/main">
               <a:ext uri="{FF2B5EF4-FFF2-40B4-BE49-F238E27FC236}">
-                <a16:creationId xmlns:a16="http://schemas.microsoft.com/office/drawing/2014/main" id="{725A16C4-8783-4220-9F16-57CE5069B192}"/>
+                <a16:creationId xmlns:a16="http://schemas.microsoft.com/office/drawing/2014/main" id="{B4650D00-5046-40CF-8A8E-5075B1CD05E7}"/>
               </a:ext>
             </a:extLst>
           </p:cNvPr>
@@ -5280,19 +5369,19 @@
           <p:cNvPr id="16" name="p3-formula-body">
             <a:extLst xmlns:a="http://schemas.openxmlformats.org/drawingml/2006/main">
               <a:ext uri="{FF2B5EF4-FFF2-40B4-BE49-F238E27FC236}">
-                <a16:creationId xmlns:a16="http://schemas.microsoft.com/office/drawing/2014/main" id="{5ABF53A6-EACE-4CD3-8929-5FF10CBE71BA}"/>
-              </a:ext>
-            </a:extLst>
-          </p:cNvPr>
-          <p:cNvSpPr>
-            <a:spLocks xmlns:a="http://schemas.openxmlformats.org/drawingml/2006/main" noGrp="1"/>
-          </p:cNvSpPr>
-          <p:nvPr/>
-        </p:nvSpPr>
-        <p:spPr>
-          <a:xfrm xmlns:a="http://schemas.openxmlformats.org/drawingml/2006/main">
-            <a:off x="6762750" y="3886200"/>
-            <a:ext cx="4095750" cy="571500"/>
+                <a16:creationId xmlns:a16="http://schemas.microsoft.com/office/drawing/2014/main" id="{DDF5DB44-DF02-4EE2-B928-426B2D6E4690}"/>
+              </a:ext>
+            </a:extLst>
+          </p:cNvPr>
+          <p:cNvSpPr>
+            <a:spLocks xmlns:a="http://schemas.openxmlformats.org/drawingml/2006/main" noGrp="1"/>
+          </p:cNvSpPr>
+          <p:nvPr/>
+        </p:nvSpPr>
+        <p:spPr>
+          <a:xfrm xmlns:a="http://schemas.openxmlformats.org/drawingml/2006/main">
+            <a:off x="6762750" y="3829050"/>
+            <a:ext cx="4095750" cy="419100"/>
           </a:xfrm>
           <a:prstGeom xmlns:a="http://schemas.openxmlformats.org/drawingml/2006/main" prst="rect">
             <a:avLst/>
@@ -5332,7 +5421,7 @@
                 <a:ea typeface="Microsoft YaHei"/>
                 <a:cs typeface="Microsoft YaHei"/>
               </a:rPr>
-              <a:t>真正想提高的，是随机工作稿达到可用标准的概率。</a:t>
+              <a:t>要提高的，是工作稿达到可用标准的概率。</a:t>
             </a:r>
           </a:p>
         </p:txBody>
@@ -5340,7 +5429,7 @@
     </p:spTree>
     <p:extLst>
       <p:ext uri="{BB962C8B-B14F-4D97-AF65-F5344CB8AC3E}">
-        <p14:creationId xmlns:p14="http://schemas.microsoft.com/office/powerpoint/2010/main" val="239256253"/>
+        <p14:creationId xmlns:p14="http://schemas.microsoft.com/office/powerpoint/2010/main" val="1999020258"/>
       </p:ext>
     </p:extLst>
   </p:cSld>
@@ -5371,7 +5460,7 @@
           <p:cNvPr id="27" name="p4-eyebrow">
             <a:extLst xmlns:a="http://schemas.openxmlformats.org/drawingml/2006/main">
               <a:ext uri="{FF2B5EF4-FFF2-40B4-BE49-F238E27FC236}">
-                <a16:creationId xmlns:a16="http://schemas.microsoft.com/office/drawing/2014/main" id="{9E85F78B-0C39-47CA-B056-44910B9EAE29}"/>
+                <a16:creationId xmlns:a16="http://schemas.microsoft.com/office/drawing/2014/main" id="{64F7E568-B50B-46C0-A7BB-665C89C98D94}"/>
               </a:ext>
             </a:extLst>
           </p:cNvPr>
@@ -5405,7 +5494,7 @@
                 <a:spcPct val="140000"/>
               </a:lnSpc>
               <a:buNone/>
-              <a:defRPr sz="900" b="1">
+              <a:defRPr sz="900" b="0">
                 <a:solidFill>
                   <a:srgbClr val="315F91"/>
                 </a:solidFill>
@@ -5415,7 +5504,7 @@
               </a:defRPr>
             </a:pPr>
             <a:r>
-              <a:rPr sz="900" b="1">
+              <a:rPr sz="900" b="0">
                 <a:solidFill>
                   <a:srgbClr val="315F91"/>
                 </a:solidFill>
@@ -5433,7 +5522,7 @@
           <p:cNvPr id="2" name="p4-title">
             <a:extLst xmlns:a="http://schemas.openxmlformats.org/drawingml/2006/main">
               <a:ext uri="{FF2B5EF4-FFF2-40B4-BE49-F238E27FC236}">
-                <a16:creationId xmlns:a16="http://schemas.microsoft.com/office/drawing/2014/main" id="{D8ECDF6F-6E0E-40F8-A0EC-B08122CB86F1}"/>
+                <a16:creationId xmlns:a16="http://schemas.microsoft.com/office/drawing/2014/main" id="{E3130315-EF2D-4529-B087-889AC014F92A}"/>
               </a:ext>
             </a:extLst>
           </p:cNvPr>
@@ -5495,7 +5584,7 @@
           <p:cNvPr id="3" name="p4-divider">
             <a:extLst xmlns:a="http://schemas.openxmlformats.org/drawingml/2006/main">
               <a:ext uri="{FF2B5EF4-FFF2-40B4-BE49-F238E27FC236}">
-                <a16:creationId xmlns:a16="http://schemas.microsoft.com/office/drawing/2014/main" id="{9CF6DADF-41CE-4D3E-B41C-C9554467D80D}"/>
+                <a16:creationId xmlns:a16="http://schemas.microsoft.com/office/drawing/2014/main" id="{272E60B8-88F4-44EF-AC70-5B017D9498EC}"/>
               </a:ext>
             </a:extLst>
           </p:cNvPr>
@@ -5526,7 +5615,7 @@
           <p:cNvPr id="4" name="p4-footer">
             <a:extLst xmlns:a="http://schemas.openxmlformats.org/drawingml/2006/main">
               <a:ext uri="{FF2B5EF4-FFF2-40B4-BE49-F238E27FC236}">
-                <a16:creationId xmlns:a16="http://schemas.microsoft.com/office/drawing/2014/main" id="{01511E9A-33B8-436A-AD54-D99BFA9A5016}"/>
+                <a16:creationId xmlns:a16="http://schemas.microsoft.com/office/drawing/2014/main" id="{8DB98773-25B4-430A-8551-B2DC580AFB49}"/>
               </a:ext>
             </a:extLst>
           </p:cNvPr>
@@ -5588,7 +5677,7 @@
           <p:cNvPr id="5" name="p4-intro">
             <a:extLst xmlns:a="http://schemas.openxmlformats.org/drawingml/2006/main">
               <a:ext uri="{FF2B5EF4-FFF2-40B4-BE49-F238E27FC236}">
-                <a16:creationId xmlns:a16="http://schemas.microsoft.com/office/drawing/2014/main" id="{8032B867-86E4-4AE3-A0D0-7E0217E32CAD}"/>
+                <a16:creationId xmlns:a16="http://schemas.microsoft.com/office/drawing/2014/main" id="{A4A90CE4-0F86-4EE4-AE3F-6B135B05736A}"/>
               </a:ext>
             </a:extLst>
           </p:cNvPr>
@@ -5650,7 +5739,7 @@
           <p:cNvPr id="6" name="p4-dim">
             <a:extLst xmlns:a="http://schemas.openxmlformats.org/drawingml/2006/main">
               <a:ext uri="{FF2B5EF4-FFF2-40B4-BE49-F238E27FC236}">
-                <a16:creationId xmlns:a16="http://schemas.microsoft.com/office/drawing/2014/main" id="{9242F761-6553-421A-BB71-7762B4BB30E1}"/>
+                <a16:creationId xmlns:a16="http://schemas.microsoft.com/office/drawing/2014/main" id="{5BBDC9A5-44CE-41C6-9D2C-44C99D2A3E80}"/>
               </a:ext>
             </a:extLst>
           </p:cNvPr>
@@ -5709,134 +5798,10 @@
       </p:sp>
       <p:sp>
         <p:nvSpPr>
-          <p:cNvPr id="7" name="p4-a-title">
-            <a:extLst xmlns:a="http://schemas.openxmlformats.org/drawingml/2006/main">
-              <a:ext uri="{FF2B5EF4-FFF2-40B4-BE49-F238E27FC236}">
-                <a16:creationId xmlns:a16="http://schemas.microsoft.com/office/drawing/2014/main" id="{A878E55F-C5A3-49C1-B666-9DFA59B74903}"/>
-              </a:ext>
-            </a:extLst>
-          </p:cNvPr>
-          <p:cNvSpPr>
-            <a:spLocks xmlns:a="http://schemas.openxmlformats.org/drawingml/2006/main" noGrp="1"/>
-          </p:cNvSpPr>
-          <p:nvPr/>
-        </p:nvSpPr>
-        <p:spPr>
-          <a:xfrm xmlns:a="http://schemas.openxmlformats.org/drawingml/2006/main">
-            <a:off x="3476625" y="1981200"/>
-            <a:ext cx="3048000" cy="342900"/>
-          </a:xfrm>
-          <a:prstGeom xmlns:a="http://schemas.openxmlformats.org/drawingml/2006/main" prst="rect">
-            <a:avLst/>
-          </a:prstGeom>
-          <a:noFill xmlns:a="http://schemas.openxmlformats.org/drawingml/2006/main"/>
-          <a:ln xmlns:a="http://schemas.openxmlformats.org/drawingml/2006/main" w="0">
-            <a:noFill/>
-            <a:prstDash val="solid"/>
-          </a:ln>
-        </p:spPr>
-        <p:txBody>
-          <a:bodyPr xmlns:a="http://schemas.openxmlformats.org/drawingml/2006/main" wrap="square" anchor="t">
-            <a:noAutofit/>
-          </a:bodyPr>
-          <a:lstStyle xmlns:a="http://schemas.openxmlformats.org/drawingml/2006/main"/>
-          <a:p xmlns:a="http://schemas.openxmlformats.org/drawingml/2006/main">
-            <a:pPr algn="l">
-              <a:lnSpc>
-                <a:spcPct val="140000"/>
-              </a:lnSpc>
-              <a:buNone/>
-              <a:defRPr sz="1575" b="1">
-                <a:solidFill>
-                  <a:srgbClr val="707780"/>
-                </a:solidFill>
-                <a:latin typeface="Microsoft YaHei"/>
-                <a:ea typeface="Microsoft YaHei"/>
-                <a:cs typeface="Microsoft YaHei"/>
-              </a:defRPr>
-            </a:pPr>
-            <a:r>
-              <a:rPr sz="1575" b="1">
-                <a:solidFill>
-                  <a:srgbClr val="707780"/>
-                </a:solidFill>
-                <a:latin typeface="Microsoft YaHei"/>
-                <a:ea typeface="Microsoft YaHei"/>
-                <a:cs typeface="Microsoft YaHei"/>
-              </a:rPr>
-              <a:t>偶然的 95 分</a:t>
-            </a:r>
-          </a:p>
-        </p:txBody>
-      </p:sp>
-      <p:sp>
-        <p:nvSpPr>
-          <p:cNvPr id="8" name="p4-b-title">
-            <a:extLst xmlns:a="http://schemas.openxmlformats.org/drawingml/2006/main">
-              <a:ext uri="{FF2B5EF4-FFF2-40B4-BE49-F238E27FC236}">
-                <a16:creationId xmlns:a16="http://schemas.microsoft.com/office/drawing/2014/main" id="{6F429063-4EF6-468B-8636-67387D75F227}"/>
-              </a:ext>
-            </a:extLst>
-          </p:cNvPr>
-          <p:cNvSpPr>
-            <a:spLocks xmlns:a="http://schemas.openxmlformats.org/drawingml/2006/main" noGrp="1"/>
-          </p:cNvSpPr>
-          <p:nvPr/>
-        </p:nvSpPr>
-        <p:spPr>
-          <a:xfrm xmlns:a="http://schemas.openxmlformats.org/drawingml/2006/main">
-            <a:off x="7953375" y="1981200"/>
-            <a:ext cx="3048000" cy="342900"/>
-          </a:xfrm>
-          <a:prstGeom xmlns:a="http://schemas.openxmlformats.org/drawingml/2006/main" prst="rect">
-            <a:avLst/>
-          </a:prstGeom>
-          <a:noFill xmlns:a="http://schemas.openxmlformats.org/drawingml/2006/main"/>
-          <a:ln xmlns:a="http://schemas.openxmlformats.org/drawingml/2006/main" w="0">
-            <a:noFill/>
-            <a:prstDash val="solid"/>
-          </a:ln>
-        </p:spPr>
-        <p:txBody>
-          <a:bodyPr xmlns:a="http://schemas.openxmlformats.org/drawingml/2006/main" wrap="square" anchor="t">
-            <a:noAutofit/>
-          </a:bodyPr>
-          <a:lstStyle xmlns:a="http://schemas.openxmlformats.org/drawingml/2006/main"/>
-          <a:p xmlns:a="http://schemas.openxmlformats.org/drawingml/2006/main">
-            <a:pPr algn="l">
-              <a:lnSpc>
-                <a:spcPct val="140000"/>
-              </a:lnSpc>
-              <a:buNone/>
-              <a:defRPr sz="1575" b="1">
-                <a:solidFill>
-                  <a:srgbClr val="315F91"/>
-                </a:solidFill>
-                <a:latin typeface="Microsoft YaHei"/>
-                <a:ea typeface="Microsoft YaHei"/>
-                <a:cs typeface="Microsoft YaHei"/>
-              </a:defRPr>
-            </a:pPr>
-            <a:r>
-              <a:rPr sz="1575" b="1">
-                <a:solidFill>
-                  <a:srgbClr val="315F91"/>
-                </a:solidFill>
-                <a:latin typeface="Microsoft YaHei"/>
-                <a:ea typeface="Microsoft YaHei"/>
-                <a:cs typeface="Microsoft YaHei"/>
-              </a:rPr>
-              <a:t>稳定的 80 分</a:t>
-            </a:r>
-          </a:p>
-        </p:txBody>
-      </p:sp>
-      <p:sp>
-        <p:nvSpPr>
-          <p:cNvPr id="9" name="p4-b-surface">
-            <a:extLst xmlns:a="http://schemas.openxmlformats.org/drawingml/2006/main">
-              <a:ext uri="{FF2B5EF4-FFF2-40B4-BE49-F238E27FC236}">
-                <a16:creationId xmlns:a16="http://schemas.microsoft.com/office/drawing/2014/main" id="{66F9AEAB-E9C5-4325-9F66-FA14370A3A6F}"/>
+          <p:cNvPr id="7" name="p4-b-surface">
+            <a:extLst xmlns:a="http://schemas.openxmlformats.org/drawingml/2006/main">
+              <a:ext uri="{FF2B5EF4-FFF2-40B4-BE49-F238E27FC236}">
+                <a16:creationId xmlns:a16="http://schemas.microsoft.com/office/drawing/2014/main" id="{B9838F7A-26CF-4B8C-80AD-DB13683D6ABD}"/>
               </a:ext>
             </a:extLst>
           </p:cNvPr>
@@ -5864,10 +5829,134 @@
       </p:sp>
       <p:sp>
         <p:nvSpPr>
+          <p:cNvPr id="8" name="p4-a-title">
+            <a:extLst xmlns:a="http://schemas.openxmlformats.org/drawingml/2006/main">
+              <a:ext uri="{FF2B5EF4-FFF2-40B4-BE49-F238E27FC236}">
+                <a16:creationId xmlns:a16="http://schemas.microsoft.com/office/drawing/2014/main" id="{BB32597A-030C-4DB7-B830-2EE82F646BC6}"/>
+              </a:ext>
+            </a:extLst>
+          </p:cNvPr>
+          <p:cNvSpPr>
+            <a:spLocks xmlns:a="http://schemas.openxmlformats.org/drawingml/2006/main" noGrp="1"/>
+          </p:cNvSpPr>
+          <p:nvPr/>
+        </p:nvSpPr>
+        <p:spPr>
+          <a:xfrm xmlns:a="http://schemas.openxmlformats.org/drawingml/2006/main">
+            <a:off x="3476625" y="1981200"/>
+            <a:ext cx="3048000" cy="342900"/>
+          </a:xfrm>
+          <a:prstGeom xmlns:a="http://schemas.openxmlformats.org/drawingml/2006/main" prst="rect">
+            <a:avLst/>
+          </a:prstGeom>
+          <a:noFill xmlns:a="http://schemas.openxmlformats.org/drawingml/2006/main"/>
+          <a:ln xmlns:a="http://schemas.openxmlformats.org/drawingml/2006/main" w="0">
+            <a:noFill/>
+            <a:prstDash val="solid"/>
+          </a:ln>
+        </p:spPr>
+        <p:txBody>
+          <a:bodyPr xmlns:a="http://schemas.openxmlformats.org/drawingml/2006/main" wrap="square" anchor="t">
+            <a:noAutofit/>
+          </a:bodyPr>
+          <a:lstStyle xmlns:a="http://schemas.openxmlformats.org/drawingml/2006/main"/>
+          <a:p xmlns:a="http://schemas.openxmlformats.org/drawingml/2006/main">
+            <a:pPr algn="l">
+              <a:lnSpc>
+                <a:spcPct val="140000"/>
+              </a:lnSpc>
+              <a:buNone/>
+              <a:defRPr sz="1575" b="1">
+                <a:solidFill>
+                  <a:srgbClr val="707780"/>
+                </a:solidFill>
+                <a:latin typeface="Microsoft YaHei"/>
+                <a:ea typeface="Microsoft YaHei"/>
+                <a:cs typeface="Microsoft YaHei"/>
+              </a:defRPr>
+            </a:pPr>
+            <a:r>
+              <a:rPr sz="1575" b="1">
+                <a:solidFill>
+                  <a:srgbClr val="707780"/>
+                </a:solidFill>
+                <a:latin typeface="Microsoft YaHei"/>
+                <a:ea typeface="Microsoft YaHei"/>
+                <a:cs typeface="Microsoft YaHei"/>
+              </a:rPr>
+              <a:t>偶然的 95 分</a:t>
+            </a:r>
+          </a:p>
+        </p:txBody>
+      </p:sp>
+      <p:sp>
+        <p:nvSpPr>
+          <p:cNvPr id="9" name="p4-b-title">
+            <a:extLst xmlns:a="http://schemas.openxmlformats.org/drawingml/2006/main">
+              <a:ext uri="{FF2B5EF4-FFF2-40B4-BE49-F238E27FC236}">
+                <a16:creationId xmlns:a16="http://schemas.microsoft.com/office/drawing/2014/main" id="{6BE1EC8A-EC99-4D54-A31F-A033A5DB67BB}"/>
+              </a:ext>
+            </a:extLst>
+          </p:cNvPr>
+          <p:cNvSpPr>
+            <a:spLocks xmlns:a="http://schemas.openxmlformats.org/drawingml/2006/main" noGrp="1"/>
+          </p:cNvSpPr>
+          <p:nvPr/>
+        </p:nvSpPr>
+        <p:spPr>
+          <a:xfrm xmlns:a="http://schemas.openxmlformats.org/drawingml/2006/main">
+            <a:off x="7953375" y="1981200"/>
+            <a:ext cx="3048000" cy="342900"/>
+          </a:xfrm>
+          <a:prstGeom xmlns:a="http://schemas.openxmlformats.org/drawingml/2006/main" prst="rect">
+            <a:avLst/>
+          </a:prstGeom>
+          <a:noFill xmlns:a="http://schemas.openxmlformats.org/drawingml/2006/main"/>
+          <a:ln xmlns:a="http://schemas.openxmlformats.org/drawingml/2006/main" w="0">
+            <a:noFill/>
+            <a:prstDash val="solid"/>
+          </a:ln>
+        </p:spPr>
+        <p:txBody>
+          <a:bodyPr xmlns:a="http://schemas.openxmlformats.org/drawingml/2006/main" wrap="square" anchor="t">
+            <a:noAutofit/>
+          </a:bodyPr>
+          <a:lstStyle xmlns:a="http://schemas.openxmlformats.org/drawingml/2006/main"/>
+          <a:p xmlns:a="http://schemas.openxmlformats.org/drawingml/2006/main">
+            <a:pPr algn="l">
+              <a:lnSpc>
+                <a:spcPct val="140000"/>
+              </a:lnSpc>
+              <a:buNone/>
+              <a:defRPr sz="1575" b="1">
+                <a:solidFill>
+                  <a:srgbClr val="315F91"/>
+                </a:solidFill>
+                <a:latin typeface="Microsoft YaHei"/>
+                <a:ea typeface="Microsoft YaHei"/>
+                <a:cs typeface="Microsoft YaHei"/>
+              </a:defRPr>
+            </a:pPr>
+            <a:r>
+              <a:rPr sz="1575" b="1">
+                <a:solidFill>
+                  <a:srgbClr val="315F91"/>
+                </a:solidFill>
+                <a:latin typeface="Microsoft YaHei"/>
+                <a:ea typeface="Microsoft YaHei"/>
+                <a:cs typeface="Microsoft YaHei"/>
+              </a:rPr>
+              <a:t>稳定的 80 分</a:t>
+            </a:r>
+          </a:p>
+        </p:txBody>
+      </p:sp>
+      <p:sp>
+        <p:nvSpPr>
           <p:cNvPr id="10" name="p4-r0-label">
             <a:extLst xmlns:a="http://schemas.openxmlformats.org/drawingml/2006/main">
               <a:ext uri="{FF2B5EF4-FFF2-40B4-BE49-F238E27FC236}">
-                <a16:creationId xmlns:a16="http://schemas.microsoft.com/office/drawing/2014/main" id="{F586F1EF-F6BE-4E0C-A3E3-119BAFE8C747}"/>
+                <a16:creationId xmlns:a16="http://schemas.microsoft.com/office/drawing/2014/main" id="{A0C370C8-07EB-4544-B4AF-6A8791A81936}"/>
               </a:ext>
             </a:extLst>
           </p:cNvPr>
@@ -5929,7 +6018,7 @@
           <p:cNvPr id="11" name="p4-r0-a">
             <a:extLst xmlns:a="http://schemas.openxmlformats.org/drawingml/2006/main">
               <a:ext uri="{FF2B5EF4-FFF2-40B4-BE49-F238E27FC236}">
-                <a16:creationId xmlns:a16="http://schemas.microsoft.com/office/drawing/2014/main" id="{B5DA4790-EBB4-48D6-8619-F19CC4CEFCAC}"/>
+                <a16:creationId xmlns:a16="http://schemas.microsoft.com/office/drawing/2014/main" id="{F164FA64-725D-440F-9756-88B0C28DA3D5}"/>
               </a:ext>
             </a:extLst>
           </p:cNvPr>
@@ -5991,7 +6080,7 @@
           <p:cNvPr id="12" name="p4-r0-b">
             <a:extLst xmlns:a="http://schemas.openxmlformats.org/drawingml/2006/main">
               <a:ext uri="{FF2B5EF4-FFF2-40B4-BE49-F238E27FC236}">
-                <a16:creationId xmlns:a16="http://schemas.microsoft.com/office/drawing/2014/main" id="{083A3451-F030-45DF-A260-FD90B25F7767}"/>
+                <a16:creationId xmlns:a16="http://schemas.microsoft.com/office/drawing/2014/main" id="{5B31C2E7-55A1-45DC-B3BB-B84110F41F6F}"/>
               </a:ext>
             </a:extLst>
           </p:cNvPr>
@@ -6053,7 +6142,7 @@
           <p:cNvPr id="13" name="p4-row-line-0">
             <a:extLst xmlns:a="http://schemas.openxmlformats.org/drawingml/2006/main">
               <a:ext uri="{FF2B5EF4-FFF2-40B4-BE49-F238E27FC236}">
-                <a16:creationId xmlns:a16="http://schemas.microsoft.com/office/drawing/2014/main" id="{A9081E58-E144-4E92-AD84-86C469BDA59F}"/>
+                <a16:creationId xmlns:a16="http://schemas.microsoft.com/office/drawing/2014/main" id="{9361D878-6EFD-4773-85D1-9535F3D86881}"/>
               </a:ext>
             </a:extLst>
           </p:cNvPr>
@@ -6084,7 +6173,7 @@
           <p:cNvPr id="14" name="p4-r1-label">
             <a:extLst xmlns:a="http://schemas.openxmlformats.org/drawingml/2006/main">
               <a:ext uri="{FF2B5EF4-FFF2-40B4-BE49-F238E27FC236}">
-                <a16:creationId xmlns:a16="http://schemas.microsoft.com/office/drawing/2014/main" id="{AEDFCCA0-8EFF-41A6-8B34-0701CBB79DD9}"/>
+                <a16:creationId xmlns:a16="http://schemas.microsoft.com/office/drawing/2014/main" id="{32D18640-7414-451C-8CAF-0AE0855761C4}"/>
               </a:ext>
             </a:extLst>
           </p:cNvPr>
@@ -6146,7 +6235,7 @@
           <p:cNvPr id="15" name="p4-r1-a">
             <a:extLst xmlns:a="http://schemas.openxmlformats.org/drawingml/2006/main">
               <a:ext uri="{FF2B5EF4-FFF2-40B4-BE49-F238E27FC236}">
-                <a16:creationId xmlns:a16="http://schemas.microsoft.com/office/drawing/2014/main" id="{1E362562-D190-44CC-AB33-047A55E661EF}"/>
+                <a16:creationId xmlns:a16="http://schemas.microsoft.com/office/drawing/2014/main" id="{4A16BB78-83A7-4BF7-BD5C-6F6BBBCB9D94}"/>
               </a:ext>
             </a:extLst>
           </p:cNvPr>
@@ -6208,7 +6297,7 @@
           <p:cNvPr id="16" name="p4-r1-b">
             <a:extLst xmlns:a="http://schemas.openxmlformats.org/drawingml/2006/main">
               <a:ext uri="{FF2B5EF4-FFF2-40B4-BE49-F238E27FC236}">
-                <a16:creationId xmlns:a16="http://schemas.microsoft.com/office/drawing/2014/main" id="{9A1B87F3-59F6-4925-AEC1-56890D25CFF5}"/>
+                <a16:creationId xmlns:a16="http://schemas.microsoft.com/office/drawing/2014/main" id="{E1832502-9B01-496C-BDD6-B7C5689BFE5A}"/>
               </a:ext>
             </a:extLst>
           </p:cNvPr>
@@ -6270,7 +6359,7 @@
           <p:cNvPr id="17" name="p4-row-line-1">
             <a:extLst xmlns:a="http://schemas.openxmlformats.org/drawingml/2006/main">
               <a:ext uri="{FF2B5EF4-FFF2-40B4-BE49-F238E27FC236}">
-                <a16:creationId xmlns:a16="http://schemas.microsoft.com/office/drawing/2014/main" id="{A11AE679-C10C-4378-B712-C950BE04245C}"/>
+                <a16:creationId xmlns:a16="http://schemas.microsoft.com/office/drawing/2014/main" id="{6B130653-F315-4126-BA3A-6BA593F40CA3}"/>
               </a:ext>
             </a:extLst>
           </p:cNvPr>
@@ -6301,7 +6390,7 @@
           <p:cNvPr id="18" name="p4-r2-label">
             <a:extLst xmlns:a="http://schemas.openxmlformats.org/drawingml/2006/main">
               <a:ext uri="{FF2B5EF4-FFF2-40B4-BE49-F238E27FC236}">
-                <a16:creationId xmlns:a16="http://schemas.microsoft.com/office/drawing/2014/main" id="{4870C0CD-19F5-4263-98D4-7A3D48E8D34A}"/>
+                <a16:creationId xmlns:a16="http://schemas.microsoft.com/office/drawing/2014/main" id="{0A17BF6A-C1BB-48E5-8C5C-6AB6B284C353}"/>
               </a:ext>
             </a:extLst>
           </p:cNvPr>
@@ -6363,7 +6452,7 @@
           <p:cNvPr id="19" name="p4-r2-a">
             <a:extLst xmlns:a="http://schemas.openxmlformats.org/drawingml/2006/main">
               <a:ext uri="{FF2B5EF4-FFF2-40B4-BE49-F238E27FC236}">
-                <a16:creationId xmlns:a16="http://schemas.microsoft.com/office/drawing/2014/main" id="{7578E100-5246-4DF6-A05B-C1DD6B7512E8}"/>
+                <a16:creationId xmlns:a16="http://schemas.microsoft.com/office/drawing/2014/main" id="{A971BD1B-0F8C-404D-8D89-50D13232D4CF}"/>
               </a:ext>
             </a:extLst>
           </p:cNvPr>
@@ -6425,7 +6514,7 @@
           <p:cNvPr id="20" name="p4-r2-b">
             <a:extLst xmlns:a="http://schemas.openxmlformats.org/drawingml/2006/main">
               <a:ext uri="{FF2B5EF4-FFF2-40B4-BE49-F238E27FC236}">
-                <a16:creationId xmlns:a16="http://schemas.microsoft.com/office/drawing/2014/main" id="{4370B22D-89C1-4268-9AC8-32FB9EA13FB5}"/>
+                <a16:creationId xmlns:a16="http://schemas.microsoft.com/office/drawing/2014/main" id="{52DE4715-17AA-4750-9029-A43E435D1D82}"/>
               </a:ext>
             </a:extLst>
           </p:cNvPr>
@@ -6487,7 +6576,7 @@
           <p:cNvPr id="21" name="p4-row-line-2">
             <a:extLst xmlns:a="http://schemas.openxmlformats.org/drawingml/2006/main">
               <a:ext uri="{FF2B5EF4-FFF2-40B4-BE49-F238E27FC236}">
-                <a16:creationId xmlns:a16="http://schemas.microsoft.com/office/drawing/2014/main" id="{7DAF86DF-D476-4C34-ADE4-94DBCA244609}"/>
+                <a16:creationId xmlns:a16="http://schemas.microsoft.com/office/drawing/2014/main" id="{E070BA94-1F4D-40B1-BCBA-D1D5C7DABD68}"/>
               </a:ext>
             </a:extLst>
           </p:cNvPr>
@@ -6518,7 +6607,7 @@
           <p:cNvPr id="22" name="p4-r3-label">
             <a:extLst xmlns:a="http://schemas.openxmlformats.org/drawingml/2006/main">
               <a:ext uri="{FF2B5EF4-FFF2-40B4-BE49-F238E27FC236}">
-                <a16:creationId xmlns:a16="http://schemas.microsoft.com/office/drawing/2014/main" id="{EB3A167D-0A37-4F73-9E14-59425DAD5CE0}"/>
+                <a16:creationId xmlns:a16="http://schemas.microsoft.com/office/drawing/2014/main" id="{8A9351A1-33B4-4CA4-B6CA-92B09D7D4D5C}"/>
               </a:ext>
             </a:extLst>
           </p:cNvPr>
@@ -6580,7 +6669,7 @@
           <p:cNvPr id="23" name="p4-r3-a">
             <a:extLst xmlns:a="http://schemas.openxmlformats.org/drawingml/2006/main">
               <a:ext uri="{FF2B5EF4-FFF2-40B4-BE49-F238E27FC236}">
-                <a16:creationId xmlns:a16="http://schemas.microsoft.com/office/drawing/2014/main" id="{BDD5F077-A8E3-4D90-8374-FE33F9991A20}"/>
+                <a16:creationId xmlns:a16="http://schemas.microsoft.com/office/drawing/2014/main" id="{9BEBF335-CB8D-45B0-ADBD-065625AD887F}"/>
               </a:ext>
             </a:extLst>
           </p:cNvPr>
@@ -6642,7 +6731,7 @@
           <p:cNvPr id="24" name="p4-r3-b">
             <a:extLst xmlns:a="http://schemas.openxmlformats.org/drawingml/2006/main">
               <a:ext uri="{FF2B5EF4-FFF2-40B4-BE49-F238E27FC236}">
-                <a16:creationId xmlns:a16="http://schemas.microsoft.com/office/drawing/2014/main" id="{F1C894C8-2142-468E-814B-72A5932F49AD}"/>
+                <a16:creationId xmlns:a16="http://schemas.microsoft.com/office/drawing/2014/main" id="{75153B0F-677C-42BD-A3BF-FB9B018B9D2A}"/>
               </a:ext>
             </a:extLst>
           </p:cNvPr>
@@ -6704,7 +6793,7 @@
           <p:cNvPr id="25" name="p4-row-line-3">
             <a:extLst xmlns:a="http://schemas.openxmlformats.org/drawingml/2006/main">
               <a:ext uri="{FF2B5EF4-FFF2-40B4-BE49-F238E27FC236}">
-                <a16:creationId xmlns:a16="http://schemas.microsoft.com/office/drawing/2014/main" id="{FDF807B2-F2D1-4AF0-8681-B601D56996DA}"/>
+                <a16:creationId xmlns:a16="http://schemas.microsoft.com/office/drawing/2014/main" id="{8437F43E-8AC1-4586-8E50-05F9E50F25C8}"/>
               </a:ext>
             </a:extLst>
           </p:cNvPr>
@@ -6735,7 +6824,7 @@
           <p:cNvPr id="26" name="p4-note">
             <a:extLst xmlns:a="http://schemas.openxmlformats.org/drawingml/2006/main">
               <a:ext uri="{FF2B5EF4-FFF2-40B4-BE49-F238E27FC236}">
-                <a16:creationId xmlns:a16="http://schemas.microsoft.com/office/drawing/2014/main" id="{324F6366-97DA-48AE-A187-CFEF55928ECF}"/>
+                <a16:creationId xmlns:a16="http://schemas.microsoft.com/office/drawing/2014/main" id="{BFBB4538-3579-416D-A2CB-568EB17E2246}"/>
               </a:ext>
             </a:extLst>
           </p:cNvPr>
@@ -6795,7 +6884,7 @@
     </p:spTree>
     <p:extLst>
       <p:ext uri="{BB962C8B-B14F-4D97-AF65-F5344CB8AC3E}">
-        <p14:creationId xmlns:p14="http://schemas.microsoft.com/office/powerpoint/2010/main" val="456137373"/>
+        <p14:creationId xmlns:p14="http://schemas.microsoft.com/office/powerpoint/2010/main" val="427668946"/>
       </p:ext>
     </p:extLst>
   </p:cSld>
@@ -6826,7 +6915,7 @@
           <p:cNvPr id="19" name="p5-eyebrow">
             <a:extLst xmlns:a="http://schemas.openxmlformats.org/drawingml/2006/main">
               <a:ext uri="{FF2B5EF4-FFF2-40B4-BE49-F238E27FC236}">
-                <a16:creationId xmlns:a16="http://schemas.microsoft.com/office/drawing/2014/main" id="{85BE0F2A-D318-467B-8B27-AD2B4ED5FFCA}"/>
+                <a16:creationId xmlns:a16="http://schemas.microsoft.com/office/drawing/2014/main" id="{65F1D728-4686-4832-9538-46F646F16D3E}"/>
               </a:ext>
             </a:extLst>
           </p:cNvPr>
@@ -6860,7 +6949,7 @@
                 <a:spcPct val="140000"/>
               </a:lnSpc>
               <a:buNone/>
-              <a:defRPr sz="900" b="1">
+              <a:defRPr sz="900" b="0">
                 <a:solidFill>
                   <a:srgbClr val="315F91"/>
                 </a:solidFill>
@@ -6870,7 +6959,7 @@
               </a:defRPr>
             </a:pPr>
             <a:r>
-              <a:rPr sz="900" b="1">
+              <a:rPr sz="900" b="0">
                 <a:solidFill>
                   <a:srgbClr val="315F91"/>
                 </a:solidFill>
@@ -6888,7 +6977,7 @@
           <p:cNvPr id="2" name="p5-title">
             <a:extLst xmlns:a="http://schemas.openxmlformats.org/drawingml/2006/main">
               <a:ext uri="{FF2B5EF4-FFF2-40B4-BE49-F238E27FC236}">
-                <a16:creationId xmlns:a16="http://schemas.microsoft.com/office/drawing/2014/main" id="{46869692-3BE7-4BD2-8D74-EDA9B306A246}"/>
+                <a16:creationId xmlns:a16="http://schemas.microsoft.com/office/drawing/2014/main" id="{8C9E91E9-CC12-4317-8E85-C045C9408AC4}"/>
               </a:ext>
             </a:extLst>
           </p:cNvPr>
@@ -6950,7 +7039,7 @@
           <p:cNvPr id="3" name="p5-divider">
             <a:extLst xmlns:a="http://schemas.openxmlformats.org/drawingml/2006/main">
               <a:ext uri="{FF2B5EF4-FFF2-40B4-BE49-F238E27FC236}">
-                <a16:creationId xmlns:a16="http://schemas.microsoft.com/office/drawing/2014/main" id="{D4103F7C-A8C2-4B73-8012-16994C99DBA1}"/>
+                <a16:creationId xmlns:a16="http://schemas.microsoft.com/office/drawing/2014/main" id="{F5B64B28-30D8-4E8D-A6B3-CF55B888DBA3}"/>
               </a:ext>
             </a:extLst>
           </p:cNvPr>
@@ -6981,7 +7070,7 @@
           <p:cNvPr id="4" name="p5-footer">
             <a:extLst xmlns:a="http://schemas.openxmlformats.org/drawingml/2006/main">
               <a:ext uri="{FF2B5EF4-FFF2-40B4-BE49-F238E27FC236}">
-                <a16:creationId xmlns:a16="http://schemas.microsoft.com/office/drawing/2014/main" id="{39EF2E0A-E3A4-464C-BBDA-B8722DB1E732}"/>
+                <a16:creationId xmlns:a16="http://schemas.microsoft.com/office/drawing/2014/main" id="{CFB630AA-5336-4580-92C2-39C15D5AADE0}"/>
               </a:ext>
             </a:extLst>
           </p:cNvPr>
@@ -7043,7 +7132,7 @@
           <p:cNvPr id="5" name="p5-intro">
             <a:extLst xmlns:a="http://schemas.openxmlformats.org/drawingml/2006/main">
               <a:ext uri="{FF2B5EF4-FFF2-40B4-BE49-F238E27FC236}">
-                <a16:creationId xmlns:a16="http://schemas.microsoft.com/office/drawing/2014/main" id="{3008325C-C8AA-4C62-8D36-79B267A6745B}"/>
+                <a16:creationId xmlns:a16="http://schemas.microsoft.com/office/drawing/2014/main" id="{4E02C225-F017-44B7-B93B-17E20ADD6967}"/>
               </a:ext>
             </a:extLst>
           </p:cNvPr>
@@ -7105,7 +7194,7 @@
           <p:cNvPr id="6" name="p5-node-0">
             <a:extLst xmlns:a="http://schemas.openxmlformats.org/drawingml/2006/main">
               <a:ext uri="{FF2B5EF4-FFF2-40B4-BE49-F238E27FC236}">
-                <a16:creationId xmlns:a16="http://schemas.microsoft.com/office/drawing/2014/main" id="{0F27A0FB-13CC-4290-905B-6EEC95E585A1}"/>
+                <a16:creationId xmlns:a16="http://schemas.microsoft.com/office/drawing/2014/main" id="{5D491589-20F6-455E-9E15-55A8C414380B}"/>
               </a:ext>
             </a:extLst>
           </p:cNvPr>
@@ -7136,7 +7225,7 @@
           <p:cNvPr id="7" name="p5-node-0-title">
             <a:extLst xmlns:a="http://schemas.openxmlformats.org/drawingml/2006/main">
               <a:ext uri="{FF2B5EF4-FFF2-40B4-BE49-F238E27FC236}">
-                <a16:creationId xmlns:a16="http://schemas.microsoft.com/office/drawing/2014/main" id="{3256B56C-6040-45CA-B24D-E72EDB21E967}"/>
+                <a16:creationId xmlns:a16="http://schemas.microsoft.com/office/drawing/2014/main" id="{D8613B0B-3918-4F4A-973F-2B46054BF947}"/>
               </a:ext>
             </a:extLst>
           </p:cNvPr>
@@ -7198,7 +7287,7 @@
           <p:cNvPr id="8" name="p5-node-0-body">
             <a:extLst xmlns:a="http://schemas.openxmlformats.org/drawingml/2006/main">
               <a:ext uri="{FF2B5EF4-FFF2-40B4-BE49-F238E27FC236}">
-                <a16:creationId xmlns:a16="http://schemas.microsoft.com/office/drawing/2014/main" id="{126BA75E-6088-4697-9759-30C7309334B8}"/>
+                <a16:creationId xmlns:a16="http://schemas.microsoft.com/office/drawing/2014/main" id="{39B0E0AA-FD1A-4301-BCB3-4A8074D53CAD}"/>
               </a:ext>
             </a:extLst>
           </p:cNvPr>
@@ -7260,7 +7349,7 @@
           <p:cNvPr id="9" name="p5-node-1">
             <a:extLst xmlns:a="http://schemas.openxmlformats.org/drawingml/2006/main">
               <a:ext uri="{FF2B5EF4-FFF2-40B4-BE49-F238E27FC236}">
-                <a16:creationId xmlns:a16="http://schemas.microsoft.com/office/drawing/2014/main" id="{F04E93B1-96B7-4F2A-8EFC-4CBF6E0C94F9}"/>
+                <a16:creationId xmlns:a16="http://schemas.microsoft.com/office/drawing/2014/main" id="{E2F07DCC-C410-45DA-8B89-4924A90D0657}"/>
               </a:ext>
             </a:extLst>
           </p:cNvPr>
@@ -7291,7 +7380,7 @@
           <p:cNvPr id="10" name="p5-node-1-title">
             <a:extLst xmlns:a="http://schemas.openxmlformats.org/drawingml/2006/main">
               <a:ext uri="{FF2B5EF4-FFF2-40B4-BE49-F238E27FC236}">
-                <a16:creationId xmlns:a16="http://schemas.microsoft.com/office/drawing/2014/main" id="{71B416D0-8113-4BA5-A1E9-1CBC944714E4}"/>
+                <a16:creationId xmlns:a16="http://schemas.microsoft.com/office/drawing/2014/main" id="{19FFF01F-F4EE-4B97-AE9B-EC6A7D5DE0BF}"/>
               </a:ext>
             </a:extLst>
           </p:cNvPr>
@@ -7353,7 +7442,7 @@
           <p:cNvPr id="11" name="p5-node-1-body">
             <a:extLst xmlns:a="http://schemas.openxmlformats.org/drawingml/2006/main">
               <a:ext uri="{FF2B5EF4-FFF2-40B4-BE49-F238E27FC236}">
-                <a16:creationId xmlns:a16="http://schemas.microsoft.com/office/drawing/2014/main" id="{A979A141-5003-447F-ADE5-2066A9C54F2C}"/>
+                <a16:creationId xmlns:a16="http://schemas.microsoft.com/office/drawing/2014/main" id="{EAD67339-02AE-411F-957D-09AA02D63FA4}"/>
               </a:ext>
             </a:extLst>
           </p:cNvPr>
@@ -7415,7 +7504,7 @@
           <p:cNvPr id="12" name="p5-node-2">
             <a:extLst xmlns:a="http://schemas.openxmlformats.org/drawingml/2006/main">
               <a:ext uri="{FF2B5EF4-FFF2-40B4-BE49-F238E27FC236}">
-                <a16:creationId xmlns:a16="http://schemas.microsoft.com/office/drawing/2014/main" id="{E03778DB-2C23-4CE1-9B2D-7A4B2AC4CE98}"/>
+                <a16:creationId xmlns:a16="http://schemas.microsoft.com/office/drawing/2014/main" id="{50890636-90E5-484C-BC27-78839CA517C7}"/>
               </a:ext>
             </a:extLst>
           </p:cNvPr>
@@ -7446,7 +7535,7 @@
           <p:cNvPr id="13" name="p5-node-2-title">
             <a:extLst xmlns:a="http://schemas.openxmlformats.org/drawingml/2006/main">
               <a:ext uri="{FF2B5EF4-FFF2-40B4-BE49-F238E27FC236}">
-                <a16:creationId xmlns:a16="http://schemas.microsoft.com/office/drawing/2014/main" id="{E6DCD113-7933-458C-89D5-D6254BEE5BF0}"/>
+                <a16:creationId xmlns:a16="http://schemas.microsoft.com/office/drawing/2014/main" id="{FBE64342-6A38-4D8E-BDB6-9C114BC5A0D0}"/>
               </a:ext>
             </a:extLst>
           </p:cNvPr>
@@ -7508,7 +7597,7 @@
           <p:cNvPr id="14" name="p5-node-2-body">
             <a:extLst xmlns:a="http://schemas.openxmlformats.org/drawingml/2006/main">
               <a:ext uri="{FF2B5EF4-FFF2-40B4-BE49-F238E27FC236}">
-                <a16:creationId xmlns:a16="http://schemas.microsoft.com/office/drawing/2014/main" id="{D510EDB6-606C-4FA4-A32B-9665A0F2AC67}"/>
+                <a16:creationId xmlns:a16="http://schemas.microsoft.com/office/drawing/2014/main" id="{FDF16997-FAF6-48B9-83EB-726B1EF23321}"/>
               </a:ext>
             </a:extLst>
           </p:cNvPr>
@@ -7620,7 +7709,7 @@
           <p:cNvPr id="17" name="p5-bottom">
             <a:extLst xmlns:a="http://schemas.openxmlformats.org/drawingml/2006/main">
               <a:ext uri="{FF2B5EF4-FFF2-40B4-BE49-F238E27FC236}">
-                <a16:creationId xmlns:a16="http://schemas.microsoft.com/office/drawing/2014/main" id="{BBBDBD6A-1C54-4D43-B5DC-ECB04A28FA0E}"/>
+                <a16:creationId xmlns:a16="http://schemas.microsoft.com/office/drawing/2014/main" id="{AE0F9719-052D-4A5D-8F8D-20474FD3822D}"/>
               </a:ext>
             </a:extLst>
           </p:cNvPr>
@@ -7682,7 +7771,7 @@
           <p:cNvPr id="18" name="p5-bottom-body">
             <a:extLst xmlns:a="http://schemas.openxmlformats.org/drawingml/2006/main">
               <a:ext uri="{FF2B5EF4-FFF2-40B4-BE49-F238E27FC236}">
-                <a16:creationId xmlns:a16="http://schemas.microsoft.com/office/drawing/2014/main" id="{31FF1B3B-34CF-4ED2-95E2-4996A9FB0F4C}"/>
+                <a16:creationId xmlns:a16="http://schemas.microsoft.com/office/drawing/2014/main" id="{43139570-4B13-4EAB-B484-881A864C978A}"/>
               </a:ext>
             </a:extLst>
           </p:cNvPr>
@@ -7742,7 +7831,7 @@
     </p:spTree>
     <p:extLst>
       <p:ext uri="{BB962C8B-B14F-4D97-AF65-F5344CB8AC3E}">
-        <p14:creationId xmlns:p14="http://schemas.microsoft.com/office/powerpoint/2010/main" val="1601742739"/>
+        <p14:creationId xmlns:p14="http://schemas.microsoft.com/office/powerpoint/2010/main" val="1350353531"/>
       </p:ext>
     </p:extLst>
   </p:cSld>
@@ -7773,7 +7862,7 @@
           <p:cNvPr id="19" name="p6-eyebrow">
             <a:extLst xmlns:a="http://schemas.openxmlformats.org/drawingml/2006/main">
               <a:ext uri="{FF2B5EF4-FFF2-40B4-BE49-F238E27FC236}">
-                <a16:creationId xmlns:a16="http://schemas.microsoft.com/office/drawing/2014/main" id="{DB1ED358-77BC-434D-9EBD-3F69E33CB98C}"/>
+                <a16:creationId xmlns:a16="http://schemas.microsoft.com/office/drawing/2014/main" id="{37195B4E-DA02-4F72-8912-3B8943DFD572}"/>
               </a:ext>
             </a:extLst>
           </p:cNvPr>
@@ -7807,7 +7896,7 @@
                 <a:spcPct val="140000"/>
               </a:lnSpc>
               <a:buNone/>
-              <a:defRPr sz="900" b="1">
+              <a:defRPr sz="900" b="0">
                 <a:solidFill>
                   <a:srgbClr val="315F91"/>
                 </a:solidFill>
@@ -7817,7 +7906,7 @@
               </a:defRPr>
             </a:pPr>
             <a:r>
-              <a:rPr sz="900" b="1">
+              <a:rPr sz="900" b="0">
                 <a:solidFill>
                   <a:srgbClr val="315F91"/>
                 </a:solidFill>
@@ -7835,7 +7924,7 @@
           <p:cNvPr id="2" name="p6-title">
             <a:extLst xmlns:a="http://schemas.openxmlformats.org/drawingml/2006/main">
               <a:ext uri="{FF2B5EF4-FFF2-40B4-BE49-F238E27FC236}">
-                <a16:creationId xmlns:a16="http://schemas.microsoft.com/office/drawing/2014/main" id="{0CE31080-979B-4DAA-983D-7B885EA0392A}"/>
+                <a16:creationId xmlns:a16="http://schemas.microsoft.com/office/drawing/2014/main" id="{338E7B7C-93B9-4466-BC3F-1F7C02B1280B}"/>
               </a:ext>
             </a:extLst>
           </p:cNvPr>
@@ -7897,7 +7986,7 @@
           <p:cNvPr id="3" name="p6-divider">
             <a:extLst xmlns:a="http://schemas.openxmlformats.org/drawingml/2006/main">
               <a:ext uri="{FF2B5EF4-FFF2-40B4-BE49-F238E27FC236}">
-                <a16:creationId xmlns:a16="http://schemas.microsoft.com/office/drawing/2014/main" id="{0DA488C1-81D4-4388-8B83-8BFD001A1253}"/>
+                <a16:creationId xmlns:a16="http://schemas.microsoft.com/office/drawing/2014/main" id="{12B046CC-517F-4F79-926D-5294E2F94508}"/>
               </a:ext>
             </a:extLst>
           </p:cNvPr>
@@ -7928,7 +8017,7 @@
           <p:cNvPr id="4" name="p6-footer">
             <a:extLst xmlns:a="http://schemas.openxmlformats.org/drawingml/2006/main">
               <a:ext uri="{FF2B5EF4-FFF2-40B4-BE49-F238E27FC236}">
-                <a16:creationId xmlns:a16="http://schemas.microsoft.com/office/drawing/2014/main" id="{AA17F927-4F79-42E8-93C3-F4D040993398}"/>
+                <a16:creationId xmlns:a16="http://schemas.microsoft.com/office/drawing/2014/main" id="{0C7D18BF-3E89-4DDB-BC96-FA6026113B94}"/>
               </a:ext>
             </a:extLst>
           </p:cNvPr>
@@ -7990,7 +8079,7 @@
           <p:cNvPr id="5" name="p6-intro">
             <a:extLst xmlns:a="http://schemas.openxmlformats.org/drawingml/2006/main">
               <a:ext uri="{FF2B5EF4-FFF2-40B4-BE49-F238E27FC236}">
-                <a16:creationId xmlns:a16="http://schemas.microsoft.com/office/drawing/2014/main" id="{6DC1ACA7-A952-489B-AEBD-1BB870E2DDB1}"/>
+                <a16:creationId xmlns:a16="http://schemas.microsoft.com/office/drawing/2014/main" id="{5227152D-9E68-4590-A31A-DBDDEC44A8E1}"/>
               </a:ext>
             </a:extLst>
           </p:cNvPr>
@@ -8052,7 +8141,7 @@
           <p:cNvPr id="6" name="p6-c0-title">
             <a:extLst xmlns:a="http://schemas.openxmlformats.org/drawingml/2006/main">
               <a:ext uri="{FF2B5EF4-FFF2-40B4-BE49-F238E27FC236}">
-                <a16:creationId xmlns:a16="http://schemas.microsoft.com/office/drawing/2014/main" id="{931B03ED-900C-465B-A278-E258D9112F35}"/>
+                <a16:creationId xmlns:a16="http://schemas.microsoft.com/office/drawing/2014/main" id="{4C7F9367-901B-4C3D-A367-FF81FD703D84}"/>
               </a:ext>
             </a:extLst>
           </p:cNvPr>
@@ -8114,7 +8203,7 @@
           <p:cNvPr id="7" name="p6-c0-line">
             <a:extLst xmlns:a="http://schemas.openxmlformats.org/drawingml/2006/main">
               <a:ext uri="{FF2B5EF4-FFF2-40B4-BE49-F238E27FC236}">
-                <a16:creationId xmlns:a16="http://schemas.microsoft.com/office/drawing/2014/main" id="{B313E10B-41C7-43D2-B0FD-318707B0CC27}"/>
+                <a16:creationId xmlns:a16="http://schemas.microsoft.com/office/drawing/2014/main" id="{EBA15838-EDA7-4F07-9679-5E5F94DC6A11}"/>
               </a:ext>
             </a:extLst>
           </p:cNvPr>
@@ -8145,7 +8234,7 @@
           <p:cNvPr id="8" name="p6-c0-body">
             <a:extLst xmlns:a="http://schemas.openxmlformats.org/drawingml/2006/main">
               <a:ext uri="{FF2B5EF4-FFF2-40B4-BE49-F238E27FC236}">
-                <a16:creationId xmlns:a16="http://schemas.microsoft.com/office/drawing/2014/main" id="{FBFCA1F3-AA8B-41C9-B262-99E1C56FE59E}"/>
+                <a16:creationId xmlns:a16="http://schemas.microsoft.com/office/drawing/2014/main" id="{1BCB9D37-2727-496B-AE0A-90A9D249AD02}"/>
               </a:ext>
             </a:extLst>
           </p:cNvPr>
@@ -8207,7 +8296,7 @@
           <p:cNvPr id="9" name="p6-c0-note">
             <a:extLst xmlns:a="http://schemas.openxmlformats.org/drawingml/2006/main">
               <a:ext uri="{FF2B5EF4-FFF2-40B4-BE49-F238E27FC236}">
-                <a16:creationId xmlns:a16="http://schemas.microsoft.com/office/drawing/2014/main" id="{3413091C-B43B-4721-8D24-AFFB186155F6}"/>
+                <a16:creationId xmlns:a16="http://schemas.microsoft.com/office/drawing/2014/main" id="{013D3CB1-C6D2-4A10-B62E-F5EDB9A20CE3}"/>
               </a:ext>
             </a:extLst>
           </p:cNvPr>
@@ -8269,7 +8358,7 @@
           <p:cNvPr id="10" name="p6-c1-title">
             <a:extLst xmlns:a="http://schemas.openxmlformats.org/drawingml/2006/main">
               <a:ext uri="{FF2B5EF4-FFF2-40B4-BE49-F238E27FC236}">
-                <a16:creationId xmlns:a16="http://schemas.microsoft.com/office/drawing/2014/main" id="{5C7F9A09-EEAC-41A5-A4B0-679ABA4DD8CA}"/>
+                <a16:creationId xmlns:a16="http://schemas.microsoft.com/office/drawing/2014/main" id="{D44F3088-778F-41B4-90E8-069FFF3235FA}"/>
               </a:ext>
             </a:extLst>
           </p:cNvPr>
@@ -8331,7 +8420,7 @@
           <p:cNvPr id="11" name="p6-c1-line">
             <a:extLst xmlns:a="http://schemas.openxmlformats.org/drawingml/2006/main">
               <a:ext uri="{FF2B5EF4-FFF2-40B4-BE49-F238E27FC236}">
-                <a16:creationId xmlns:a16="http://schemas.microsoft.com/office/drawing/2014/main" id="{8E16E47F-5FB4-473F-B2AD-99B7464844E0}"/>
+                <a16:creationId xmlns:a16="http://schemas.microsoft.com/office/drawing/2014/main" id="{57F0B473-35FC-46CE-85E6-8F8C8A065A39}"/>
               </a:ext>
             </a:extLst>
           </p:cNvPr>
@@ -8362,7 +8451,7 @@
           <p:cNvPr id="12" name="p6-c1-body">
             <a:extLst xmlns:a="http://schemas.openxmlformats.org/drawingml/2006/main">
               <a:ext uri="{FF2B5EF4-FFF2-40B4-BE49-F238E27FC236}">
-                <a16:creationId xmlns:a16="http://schemas.microsoft.com/office/drawing/2014/main" id="{D86A0600-DBCB-4B9D-B5DD-B91F500C5CDB}"/>
+                <a16:creationId xmlns:a16="http://schemas.microsoft.com/office/drawing/2014/main" id="{99CE6CE2-2ED7-4805-9933-70728C9E5D58}"/>
               </a:ext>
             </a:extLst>
           </p:cNvPr>
@@ -8424,7 +8513,7 @@
           <p:cNvPr id="13" name="p6-c1-note">
             <a:extLst xmlns:a="http://schemas.openxmlformats.org/drawingml/2006/main">
               <a:ext uri="{FF2B5EF4-FFF2-40B4-BE49-F238E27FC236}">
-                <a16:creationId xmlns:a16="http://schemas.microsoft.com/office/drawing/2014/main" id="{F470DF95-99E0-4201-9937-7DB6CB4E8B8C}"/>
+                <a16:creationId xmlns:a16="http://schemas.microsoft.com/office/drawing/2014/main" id="{15A821C9-06CC-47AA-91B9-7682C1CBD6C0}"/>
               </a:ext>
             </a:extLst>
           </p:cNvPr>
@@ -8486,7 +8575,7 @@
           <p:cNvPr id="14" name="p6-c2-title">
             <a:extLst xmlns:a="http://schemas.openxmlformats.org/drawingml/2006/main">
               <a:ext uri="{FF2B5EF4-FFF2-40B4-BE49-F238E27FC236}">
-                <a16:creationId xmlns:a16="http://schemas.microsoft.com/office/drawing/2014/main" id="{94761135-224C-46E7-8CB4-5A3C41F5D6EE}"/>
+                <a16:creationId xmlns:a16="http://schemas.microsoft.com/office/drawing/2014/main" id="{8D0B108B-2457-48C8-B043-3BEB5AB087B8}"/>
               </a:ext>
             </a:extLst>
           </p:cNvPr>
@@ -8548,7 +8637,7 @@
           <p:cNvPr id="15" name="p6-c2-line">
             <a:extLst xmlns:a="http://schemas.openxmlformats.org/drawingml/2006/main">
               <a:ext uri="{FF2B5EF4-FFF2-40B4-BE49-F238E27FC236}">
-                <a16:creationId xmlns:a16="http://schemas.microsoft.com/office/drawing/2014/main" id="{DA21B15F-13B1-4657-B5F1-22D8B33EC756}"/>
+                <a16:creationId xmlns:a16="http://schemas.microsoft.com/office/drawing/2014/main" id="{E14055AE-C5DF-4F53-98D3-6520A3FBE626}"/>
               </a:ext>
             </a:extLst>
           </p:cNvPr>
@@ -8579,7 +8668,7 @@
           <p:cNvPr id="16" name="p6-c2-body">
             <a:extLst xmlns:a="http://schemas.openxmlformats.org/drawingml/2006/main">
               <a:ext uri="{FF2B5EF4-FFF2-40B4-BE49-F238E27FC236}">
-                <a16:creationId xmlns:a16="http://schemas.microsoft.com/office/drawing/2014/main" id="{DF8297E2-807A-4ED7-80EB-E19438AA226F}"/>
+                <a16:creationId xmlns:a16="http://schemas.microsoft.com/office/drawing/2014/main" id="{EBB2C3DC-CF00-4B90-990D-A8DC6468CF9A}"/>
               </a:ext>
             </a:extLst>
           </p:cNvPr>
@@ -8641,7 +8730,7 @@
           <p:cNvPr id="17" name="p6-c2-note">
             <a:extLst xmlns:a="http://schemas.openxmlformats.org/drawingml/2006/main">
               <a:ext uri="{FF2B5EF4-FFF2-40B4-BE49-F238E27FC236}">
-                <a16:creationId xmlns:a16="http://schemas.microsoft.com/office/drawing/2014/main" id="{86EDB8EE-5E7C-4DB0-824B-03DD291EE98A}"/>
+                <a16:creationId xmlns:a16="http://schemas.microsoft.com/office/drawing/2014/main" id="{0C07CFE4-925B-417A-A9A7-CDD7F9957423}"/>
               </a:ext>
             </a:extLst>
           </p:cNvPr>
@@ -8703,7 +8792,7 @@
           <p:cNvPr id="18" name="p6-quote">
             <a:extLst xmlns:a="http://schemas.openxmlformats.org/drawingml/2006/main">
               <a:ext uri="{FF2B5EF4-FFF2-40B4-BE49-F238E27FC236}">
-                <a16:creationId xmlns:a16="http://schemas.microsoft.com/office/drawing/2014/main" id="{94E88165-716A-44D6-A947-A459107156A9}"/>
+                <a16:creationId xmlns:a16="http://schemas.microsoft.com/office/drawing/2014/main" id="{EDC3FAF2-A260-45BC-9AFB-A28295ADB3F4}"/>
               </a:ext>
             </a:extLst>
           </p:cNvPr>
@@ -8763,7 +8852,7 @@
     </p:spTree>
     <p:extLst>
       <p:ext uri="{BB962C8B-B14F-4D97-AF65-F5344CB8AC3E}">
-        <p14:creationId xmlns:p14="http://schemas.microsoft.com/office/powerpoint/2010/main" val="1507583546"/>
+        <p14:creationId xmlns:p14="http://schemas.microsoft.com/office/powerpoint/2010/main" val="1417329722"/>
       </p:ext>
     </p:extLst>
   </p:cSld>
@@ -8794,7 +8883,7 @@
           <p:cNvPr id="31" name="p7-eyebrow">
             <a:extLst xmlns:a="http://schemas.openxmlformats.org/drawingml/2006/main">
               <a:ext uri="{FF2B5EF4-FFF2-40B4-BE49-F238E27FC236}">
-                <a16:creationId xmlns:a16="http://schemas.microsoft.com/office/drawing/2014/main" id="{A3D250C8-4CFE-4170-B5C0-DE64E392CC45}"/>
+                <a16:creationId xmlns:a16="http://schemas.microsoft.com/office/drawing/2014/main" id="{81BF9FD0-C519-48A3-B2EA-4E859B8DBE2C}"/>
               </a:ext>
             </a:extLst>
           </p:cNvPr>
@@ -8828,7 +8917,7 @@
                 <a:spcPct val="140000"/>
               </a:lnSpc>
               <a:buNone/>
-              <a:defRPr sz="900" b="1">
+              <a:defRPr sz="900" b="0">
                 <a:solidFill>
                   <a:srgbClr val="315F91"/>
                 </a:solidFill>
@@ -8838,7 +8927,7 @@
               </a:defRPr>
             </a:pPr>
             <a:r>
-              <a:rPr sz="900" b="1">
+              <a:rPr sz="900" b="0">
                 <a:solidFill>
                   <a:srgbClr val="315F91"/>
                 </a:solidFill>
@@ -8856,7 +8945,7 @@
           <p:cNvPr id="2" name="p7-title">
             <a:extLst xmlns:a="http://schemas.openxmlformats.org/drawingml/2006/main">
               <a:ext uri="{FF2B5EF4-FFF2-40B4-BE49-F238E27FC236}">
-                <a16:creationId xmlns:a16="http://schemas.microsoft.com/office/drawing/2014/main" id="{781C4F67-2E87-40B9-9A69-4AE1207FBDCD}"/>
+                <a16:creationId xmlns:a16="http://schemas.microsoft.com/office/drawing/2014/main" id="{E82B80A1-FF9E-4E3E-9F85-2C9E054043EA}"/>
               </a:ext>
             </a:extLst>
           </p:cNvPr>
@@ -8918,7 +9007,7 @@
           <p:cNvPr id="3" name="p7-divider">
             <a:extLst xmlns:a="http://schemas.openxmlformats.org/drawingml/2006/main">
               <a:ext uri="{FF2B5EF4-FFF2-40B4-BE49-F238E27FC236}">
-                <a16:creationId xmlns:a16="http://schemas.microsoft.com/office/drawing/2014/main" id="{9E759A0C-7253-4943-A82C-4C26520343C9}"/>
+                <a16:creationId xmlns:a16="http://schemas.microsoft.com/office/drawing/2014/main" id="{E2D80631-54F9-451E-803D-496B72831582}"/>
               </a:ext>
             </a:extLst>
           </p:cNvPr>
@@ -8949,7 +9038,7 @@
           <p:cNvPr id="4" name="p7-footer">
             <a:extLst xmlns:a="http://schemas.openxmlformats.org/drawingml/2006/main">
               <a:ext uri="{FF2B5EF4-FFF2-40B4-BE49-F238E27FC236}">
-                <a16:creationId xmlns:a16="http://schemas.microsoft.com/office/drawing/2014/main" id="{4A694727-BF12-4344-B560-C907FECEF50D}"/>
+                <a16:creationId xmlns:a16="http://schemas.microsoft.com/office/drawing/2014/main" id="{6C25286F-EC82-41CF-B8E5-0A20D8C90737}"/>
               </a:ext>
             </a:extLst>
           </p:cNvPr>
@@ -9011,7 +9100,7 @@
           <p:cNvPr id="5" name="p7-intro">
             <a:extLst xmlns:a="http://schemas.openxmlformats.org/drawingml/2006/main">
               <a:ext uri="{FF2B5EF4-FFF2-40B4-BE49-F238E27FC236}">
-                <a16:creationId xmlns:a16="http://schemas.microsoft.com/office/drawing/2014/main" id="{2BEE529D-45FF-486A-96A8-72DF14A6F993}"/>
+                <a16:creationId xmlns:a16="http://schemas.microsoft.com/office/drawing/2014/main" id="{F65A025E-5D02-4AD9-A009-2AF6240C4A84}"/>
               </a:ext>
             </a:extLst>
           </p:cNvPr>
@@ -9073,7 +9162,7 @@
           <p:cNvPr id="6" name="p7-build-label">
             <a:extLst xmlns:a="http://schemas.openxmlformats.org/drawingml/2006/main">
               <a:ext uri="{FF2B5EF4-FFF2-40B4-BE49-F238E27FC236}">
-                <a16:creationId xmlns:a16="http://schemas.microsoft.com/office/drawing/2014/main" id="{E3EDD11C-91AE-4FAC-BCD5-D9DC6DA09292}"/>
+                <a16:creationId xmlns:a16="http://schemas.microsoft.com/office/drawing/2014/main" id="{1223EC79-2C5F-4BF9-882F-FB695C612CAD}"/>
               </a:ext>
             </a:extLst>
           </p:cNvPr>
@@ -9135,7 +9224,7 @@
           <p:cNvPr id="7" name="p7-run-label">
             <a:extLst xmlns:a="http://schemas.openxmlformats.org/drawingml/2006/main">
               <a:ext uri="{FF2B5EF4-FFF2-40B4-BE49-F238E27FC236}">
-                <a16:creationId xmlns:a16="http://schemas.microsoft.com/office/drawing/2014/main" id="{9F075C31-809E-47A0-B350-EA5B71DF3C99}"/>
+                <a16:creationId xmlns:a16="http://schemas.microsoft.com/office/drawing/2014/main" id="{D391B1C5-6952-4AFE-8874-4854614A48A6}"/>
               </a:ext>
             </a:extLst>
           </p:cNvPr>
@@ -9197,7 +9286,7 @@
           <p:cNvPr id="8" name="p7-b1-bg">
             <a:extLst xmlns:a="http://schemas.openxmlformats.org/drawingml/2006/main">
               <a:ext uri="{FF2B5EF4-FFF2-40B4-BE49-F238E27FC236}">
-                <a16:creationId xmlns:a16="http://schemas.microsoft.com/office/drawing/2014/main" id="{FFA5B3B1-71B1-4345-B342-61CE61A8C672}"/>
+                <a16:creationId xmlns:a16="http://schemas.microsoft.com/office/drawing/2014/main" id="{BAD77D26-30A8-48B6-B458-5E8F21ACC6DF}"/>
               </a:ext>
             </a:extLst>
           </p:cNvPr>
@@ -9228,7 +9317,7 @@
           <p:cNvPr id="9" name="p7-b1">
             <a:extLst xmlns:a="http://schemas.openxmlformats.org/drawingml/2006/main">
               <a:ext uri="{FF2B5EF4-FFF2-40B4-BE49-F238E27FC236}">
-                <a16:creationId xmlns:a16="http://schemas.microsoft.com/office/drawing/2014/main" id="{A15568D8-6414-4A5D-8A60-15D01B873D9A}"/>
+                <a16:creationId xmlns:a16="http://schemas.microsoft.com/office/drawing/2014/main" id="{DDBA413E-3A99-4571-A8B2-E4CB88CC86DF}"/>
               </a:ext>
             </a:extLst>
           </p:cNvPr>
@@ -9290,7 +9379,7 @@
           <p:cNvPr id="10" name="p7-b2-bg">
             <a:extLst xmlns:a="http://schemas.openxmlformats.org/drawingml/2006/main">
               <a:ext uri="{FF2B5EF4-FFF2-40B4-BE49-F238E27FC236}">
-                <a16:creationId xmlns:a16="http://schemas.microsoft.com/office/drawing/2014/main" id="{D034B34F-0776-4A99-ADD2-3CD4878E2C52}"/>
+                <a16:creationId xmlns:a16="http://schemas.microsoft.com/office/drawing/2014/main" id="{7BE57918-743A-48B8-A16B-CEEA8DC0AC51}"/>
               </a:ext>
             </a:extLst>
           </p:cNvPr>
@@ -9321,7 +9410,7 @@
           <p:cNvPr id="11" name="p7-b2">
             <a:extLst xmlns:a="http://schemas.openxmlformats.org/drawingml/2006/main">
               <a:ext uri="{FF2B5EF4-FFF2-40B4-BE49-F238E27FC236}">
-                <a16:creationId xmlns:a16="http://schemas.microsoft.com/office/drawing/2014/main" id="{C84D5C05-8038-4EC3-8210-927A2385CCF2}"/>
+                <a16:creationId xmlns:a16="http://schemas.microsoft.com/office/drawing/2014/main" id="{6F650AD5-A91E-4D99-B720-C356771BF967}"/>
               </a:ext>
             </a:extLst>
           </p:cNvPr>
@@ -9383,7 +9472,7 @@
           <p:cNvPr id="12" name="p7-b3-bg">
             <a:extLst xmlns:a="http://schemas.openxmlformats.org/drawingml/2006/main">
               <a:ext uri="{FF2B5EF4-FFF2-40B4-BE49-F238E27FC236}">
-                <a16:creationId xmlns:a16="http://schemas.microsoft.com/office/drawing/2014/main" id="{10587D17-EF40-47EA-BCC6-5CA064AFC3AD}"/>
+                <a16:creationId xmlns:a16="http://schemas.microsoft.com/office/drawing/2014/main" id="{A8105799-6CBB-4124-8579-229884E2BF39}"/>
               </a:ext>
             </a:extLst>
           </p:cNvPr>
@@ -9414,7 +9503,7 @@
           <p:cNvPr id="13" name="p7-b3">
             <a:extLst xmlns:a="http://schemas.openxmlformats.org/drawingml/2006/main">
               <a:ext uri="{FF2B5EF4-FFF2-40B4-BE49-F238E27FC236}">
-                <a16:creationId xmlns:a16="http://schemas.microsoft.com/office/drawing/2014/main" id="{C563AB3C-4A77-4DB2-B8E4-8482743106F2}"/>
+                <a16:creationId xmlns:a16="http://schemas.microsoft.com/office/drawing/2014/main" id="{E7878381-DBC8-4DF1-91C4-12CB01D0B5FF}"/>
               </a:ext>
             </a:extLst>
           </p:cNvPr>
@@ -9526,7 +9615,7 @@
           <p:cNvPr id="16" name="p7-core-bg">
             <a:extLst xmlns:a="http://schemas.openxmlformats.org/drawingml/2006/main">
               <a:ext uri="{FF2B5EF4-FFF2-40B4-BE49-F238E27FC236}">
-                <a16:creationId xmlns:a16="http://schemas.microsoft.com/office/drawing/2014/main" id="{CF6F0193-797C-45E0-970B-A059A3ADF6FE}"/>
+                <a16:creationId xmlns:a16="http://schemas.microsoft.com/office/drawing/2014/main" id="{C897EA53-E2E9-44F9-BF54-1A20B686B9CE}"/>
               </a:ext>
             </a:extLst>
           </p:cNvPr>
@@ -9557,7 +9646,7 @@
           <p:cNvPr id="17" name="p7-core">
             <a:extLst xmlns:a="http://schemas.openxmlformats.org/drawingml/2006/main">
               <a:ext uri="{FF2B5EF4-FFF2-40B4-BE49-F238E27FC236}">
-                <a16:creationId xmlns:a16="http://schemas.microsoft.com/office/drawing/2014/main" id="{849AD9BB-5CC1-4757-BABA-AD23929F27AE}"/>
+                <a16:creationId xmlns:a16="http://schemas.microsoft.com/office/drawing/2014/main" id="{0787D698-389C-4425-A9B1-0CC73F59F2D9}"/>
               </a:ext>
             </a:extLst>
           </p:cNvPr>
@@ -9644,7 +9733,7 @@
           <p:cNvPr id="19" name="p7-r1-bg">
             <a:extLst xmlns:a="http://schemas.openxmlformats.org/drawingml/2006/main">
               <a:ext uri="{FF2B5EF4-FFF2-40B4-BE49-F238E27FC236}">
-                <a16:creationId xmlns:a16="http://schemas.microsoft.com/office/drawing/2014/main" id="{EB56AFD3-F075-4065-A56D-45B75F7C6DAE}"/>
+                <a16:creationId xmlns:a16="http://schemas.microsoft.com/office/drawing/2014/main" id="{28C44921-2A88-4090-9E4C-E0197FAE1E3C}"/>
               </a:ext>
             </a:extLst>
           </p:cNvPr>
@@ -9675,7 +9764,7 @@
           <p:cNvPr id="20" name="p7-r1">
             <a:extLst xmlns:a="http://schemas.openxmlformats.org/drawingml/2006/main">
               <a:ext uri="{FF2B5EF4-FFF2-40B4-BE49-F238E27FC236}">
-                <a16:creationId xmlns:a16="http://schemas.microsoft.com/office/drawing/2014/main" id="{943E8007-97B7-4370-8992-425DD6F488D0}"/>
+                <a16:creationId xmlns:a16="http://schemas.microsoft.com/office/drawing/2014/main" id="{2F5F4608-4893-4641-8B1B-78FF27A6AC4E}"/>
               </a:ext>
             </a:extLst>
           </p:cNvPr>
@@ -9737,7 +9826,7 @@
           <p:cNvPr id="21" name="p7-r2-bg">
             <a:extLst xmlns:a="http://schemas.openxmlformats.org/drawingml/2006/main">
               <a:ext uri="{FF2B5EF4-FFF2-40B4-BE49-F238E27FC236}">
-                <a16:creationId xmlns:a16="http://schemas.microsoft.com/office/drawing/2014/main" id="{E68B0576-E783-49E7-82FA-B014600C1CD6}"/>
+                <a16:creationId xmlns:a16="http://schemas.microsoft.com/office/drawing/2014/main" id="{C0E646ED-8F52-4E2B-A915-ABE9266CEE78}"/>
               </a:ext>
             </a:extLst>
           </p:cNvPr>
@@ -9768,7 +9857,7 @@
           <p:cNvPr id="22" name="p7-r2">
             <a:extLst xmlns:a="http://schemas.openxmlformats.org/drawingml/2006/main">
               <a:ext uri="{FF2B5EF4-FFF2-40B4-BE49-F238E27FC236}">
-                <a16:creationId xmlns:a16="http://schemas.microsoft.com/office/drawing/2014/main" id="{F864F0D5-C730-47CC-BEF5-FB609DF17596}"/>
+                <a16:creationId xmlns:a16="http://schemas.microsoft.com/office/drawing/2014/main" id="{2D4471B0-6280-40D9-9BDE-0DBB8AF90BE1}"/>
               </a:ext>
             </a:extLst>
           </p:cNvPr>
@@ -9830,7 +9919,7 @@
           <p:cNvPr id="23" name="p7-r3-bg">
             <a:extLst xmlns:a="http://schemas.openxmlformats.org/drawingml/2006/main">
               <a:ext uri="{FF2B5EF4-FFF2-40B4-BE49-F238E27FC236}">
-                <a16:creationId xmlns:a16="http://schemas.microsoft.com/office/drawing/2014/main" id="{B715FC99-F537-4102-9CA7-7E6EF87693CE}"/>
+                <a16:creationId xmlns:a16="http://schemas.microsoft.com/office/drawing/2014/main" id="{EA26D962-EB86-4B7C-8008-BBD325C405E1}"/>
               </a:ext>
             </a:extLst>
           </p:cNvPr>
@@ -9861,7 +9950,7 @@
           <p:cNvPr id="24" name="p7-r3">
             <a:extLst xmlns:a="http://schemas.openxmlformats.org/drawingml/2006/main">
               <a:ext uri="{FF2B5EF4-FFF2-40B4-BE49-F238E27FC236}">
-                <a16:creationId xmlns:a16="http://schemas.microsoft.com/office/drawing/2014/main" id="{3BA79FE6-670F-409C-9903-DCBFB01CF24D}"/>
+                <a16:creationId xmlns:a16="http://schemas.microsoft.com/office/drawing/2014/main" id="{1FADA610-2309-4126-85AD-AADE82ACE02F}"/>
               </a:ext>
             </a:extLst>
           </p:cNvPr>
@@ -9998,7 +10087,7 @@
           <p:cNvPr id="28" name="p7-out">
             <a:extLst xmlns:a="http://schemas.openxmlformats.org/drawingml/2006/main">
               <a:ext uri="{FF2B5EF4-FFF2-40B4-BE49-F238E27FC236}">
-                <a16:creationId xmlns:a16="http://schemas.microsoft.com/office/drawing/2014/main" id="{71E5CA55-2AD6-4316-9964-C24245BD5E0C}"/>
+                <a16:creationId xmlns:a16="http://schemas.microsoft.com/office/drawing/2014/main" id="{4C9950C6-9D6C-4CF7-91A8-91B9DDE5677D}"/>
               </a:ext>
             </a:extLst>
           </p:cNvPr>
@@ -10085,19 +10174,19 @@
           <p:cNvPr id="30" name="p7-note">
             <a:extLst xmlns:a="http://schemas.openxmlformats.org/drawingml/2006/main">
               <a:ext uri="{FF2B5EF4-FFF2-40B4-BE49-F238E27FC236}">
-                <a16:creationId xmlns:a16="http://schemas.microsoft.com/office/drawing/2014/main" id="{FBE85D63-336A-4E97-8552-1C7C7B33E5BF}"/>
-              </a:ext>
-            </a:extLst>
-          </p:cNvPr>
-          <p:cNvSpPr>
-            <a:spLocks xmlns:a="http://schemas.openxmlformats.org/drawingml/2006/main" noGrp="1"/>
-          </p:cNvSpPr>
-          <p:nvPr/>
-        </p:nvSpPr>
-        <p:spPr>
-          <a:xfrm xmlns:a="http://schemas.openxmlformats.org/drawingml/2006/main">
-            <a:off x="704850" y="5734050"/>
-            <a:ext cx="10477500" cy="304800"/>
+                <a16:creationId xmlns:a16="http://schemas.microsoft.com/office/drawing/2014/main" id="{0A97E48C-8B6A-4067-9058-02EEA403A993}"/>
+              </a:ext>
+            </a:extLst>
+          </p:cNvPr>
+          <p:cNvSpPr>
+            <a:spLocks xmlns:a="http://schemas.openxmlformats.org/drawingml/2006/main" noGrp="1"/>
+          </p:cNvSpPr>
+          <p:nvPr/>
+        </p:nvSpPr>
+        <p:spPr>
+          <a:xfrm xmlns:a="http://schemas.openxmlformats.org/drawingml/2006/main">
+            <a:off x="704850" y="5619750"/>
+            <a:ext cx="10477500" cy="590550"/>
           </a:xfrm>
           <a:prstGeom xmlns:a="http://schemas.openxmlformats.org/drawingml/2006/main" prst="rect">
             <a:avLst/>
@@ -10138,6 +10227,33 @@
                 <a:cs typeface="Microsoft YaHei"/>
               </a:rPr>
               <a:t>两条路线的唯一交汇点，是经过确认的核心资产库。</a:t>
+            </a:r>
+          </a:p>
+          <a:p xmlns:a="http://schemas.openxmlformats.org/drawingml/2006/main">
+            <a:pPr algn="l">
+              <a:lnSpc>
+                <a:spcPct val="140000"/>
+              </a:lnSpc>
+              <a:buNone/>
+              <a:defRPr sz="1200" b="0">
+                <a:solidFill>
+                  <a:srgbClr val="707780"/>
+                </a:solidFill>
+                <a:latin typeface="Microsoft YaHei"/>
+                <a:ea typeface="Microsoft YaHei"/>
+                <a:cs typeface="Microsoft YaHei"/>
+              </a:defRPr>
+            </a:pPr>
+            <a:r>
+              <a:rPr sz="1200" b="0">
+                <a:solidFill>
+                  <a:srgbClr val="707780"/>
+                </a:solidFill>
+                <a:latin typeface="Microsoft YaHei"/>
+                <a:ea typeface="Microsoft YaHei"/>
+                <a:cs typeface="Microsoft YaHei"/>
+              </a:rPr>
+              <a:t>没有合适结构时，退回简单排版 / 拆页；缺口是否另行建设，由用户决定。</a:t>
             </a:r>
           </a:p>
         </p:txBody>
@@ -10145,7 +10261,7 @@
     </p:spTree>
     <p:extLst>
       <p:ext uri="{BB962C8B-B14F-4D97-AF65-F5344CB8AC3E}">
-        <p14:creationId xmlns:p14="http://schemas.microsoft.com/office/powerpoint/2010/main" val="156403743"/>
+        <p14:creationId xmlns:p14="http://schemas.microsoft.com/office/powerpoint/2010/main" val="1340379287"/>
       </p:ext>
     </p:extLst>
   </p:cSld>
@@ -10176,7 +10292,7 @@
           <p:cNvPr id="14" name="p8-eyebrow">
             <a:extLst xmlns:a="http://schemas.openxmlformats.org/drawingml/2006/main">
               <a:ext uri="{FF2B5EF4-FFF2-40B4-BE49-F238E27FC236}">
-                <a16:creationId xmlns:a16="http://schemas.microsoft.com/office/drawing/2014/main" id="{ECF615D0-6EE2-4AEA-B148-A3012D80D707}"/>
+                <a16:creationId xmlns:a16="http://schemas.microsoft.com/office/drawing/2014/main" id="{CCE3857D-8377-4975-9232-FAD795829294}"/>
               </a:ext>
             </a:extLst>
           </p:cNvPr>
@@ -10210,7 +10326,7 @@
                 <a:spcPct val="140000"/>
               </a:lnSpc>
               <a:buNone/>
-              <a:defRPr sz="900" b="1">
+              <a:defRPr sz="900" b="0">
                 <a:solidFill>
                   <a:srgbClr val="315F91"/>
                 </a:solidFill>
@@ -10220,7 +10336,7 @@
               </a:defRPr>
             </a:pPr>
             <a:r>
-              <a:rPr sz="900" b="1">
+              <a:rPr sz="900" b="0">
                 <a:solidFill>
                   <a:srgbClr val="315F91"/>
                 </a:solidFill>
@@ -10238,7 +10354,7 @@
           <p:cNvPr id="2" name="p8-title">
             <a:extLst xmlns:a="http://schemas.openxmlformats.org/drawingml/2006/main">
               <a:ext uri="{FF2B5EF4-FFF2-40B4-BE49-F238E27FC236}">
-                <a16:creationId xmlns:a16="http://schemas.microsoft.com/office/drawing/2014/main" id="{DC2A2DF2-29DE-4373-87CA-0423B83E1D35}"/>
+                <a16:creationId xmlns:a16="http://schemas.microsoft.com/office/drawing/2014/main" id="{0B029BB5-9AF4-4DA4-BA5C-062440E7BACF}"/>
               </a:ext>
             </a:extLst>
           </p:cNvPr>
@@ -10300,7 +10416,7 @@
           <p:cNvPr id="3" name="p8-divider">
             <a:extLst xmlns:a="http://schemas.openxmlformats.org/drawingml/2006/main">
               <a:ext uri="{FF2B5EF4-FFF2-40B4-BE49-F238E27FC236}">
-                <a16:creationId xmlns:a16="http://schemas.microsoft.com/office/drawing/2014/main" id="{966350A8-3419-4093-852E-901E172B9853}"/>
+                <a16:creationId xmlns:a16="http://schemas.microsoft.com/office/drawing/2014/main" id="{D7CF6E54-0055-4F46-B852-169A17079F3B}"/>
               </a:ext>
             </a:extLst>
           </p:cNvPr>
@@ -10331,7 +10447,7 @@
           <p:cNvPr id="4" name="p8-footer">
             <a:extLst xmlns:a="http://schemas.openxmlformats.org/drawingml/2006/main">
               <a:ext uri="{FF2B5EF4-FFF2-40B4-BE49-F238E27FC236}">
-                <a16:creationId xmlns:a16="http://schemas.microsoft.com/office/drawing/2014/main" id="{2033E034-6EC8-43C0-8A33-85026BC7C09F}"/>
+                <a16:creationId xmlns:a16="http://schemas.microsoft.com/office/drawing/2014/main" id="{6B15ED61-F20D-4145-B4E3-C360AF055C05}"/>
               </a:ext>
             </a:extLst>
           </p:cNvPr>
@@ -10393,7 +10509,7 @@
           <p:cNvPr id="5" name="p8-intro">
             <a:extLst xmlns:a="http://schemas.openxmlformats.org/drawingml/2006/main">
               <a:ext uri="{FF2B5EF4-FFF2-40B4-BE49-F238E27FC236}">
-                <a16:creationId xmlns:a16="http://schemas.microsoft.com/office/drawing/2014/main" id="{52035E41-13AD-4877-A2EC-BC29B948B264}"/>
+                <a16:creationId xmlns:a16="http://schemas.microsoft.com/office/drawing/2014/main" id="{2634EB34-EE6D-4C0F-9C4E-664B13E54588}"/>
               </a:ext>
             </a:extLst>
           </p:cNvPr>
@@ -10455,7 +10571,7 @@
           <p:cNvPr id="6" name="p8-build-title">
             <a:extLst xmlns:a="http://schemas.openxmlformats.org/drawingml/2006/main">
               <a:ext uri="{FF2B5EF4-FFF2-40B4-BE49-F238E27FC236}">
-                <a16:creationId xmlns:a16="http://schemas.microsoft.com/office/drawing/2014/main" id="{916D5A30-E0DB-48C6-A750-CF3429A5A848}"/>
+                <a16:creationId xmlns:a16="http://schemas.microsoft.com/office/drawing/2014/main" id="{F3E858BE-0F1A-4F32-B080-EC38F42CBAF2}"/>
               </a:ext>
             </a:extLst>
           </p:cNvPr>
@@ -10517,7 +10633,7 @@
           <p:cNvPr id="7" name="p8-build-surface">
             <a:extLst xmlns:a="http://schemas.openxmlformats.org/drawingml/2006/main">
               <a:ext uri="{FF2B5EF4-FFF2-40B4-BE49-F238E27FC236}">
-                <a16:creationId xmlns:a16="http://schemas.microsoft.com/office/drawing/2014/main" id="{7FB00E14-1F13-4ED0-B1B1-ABF2316E8E51}"/>
+                <a16:creationId xmlns:a16="http://schemas.microsoft.com/office/drawing/2014/main" id="{B15D3AC5-6FE6-4ECE-81D8-A5829680DABF}"/>
               </a:ext>
             </a:extLst>
           </p:cNvPr>
@@ -10548,7 +10664,7 @@
           <p:cNvPr id="8" name="p8-build-over">
             <a:extLst xmlns:a="http://schemas.openxmlformats.org/drawingml/2006/main">
               <a:ext uri="{FF2B5EF4-FFF2-40B4-BE49-F238E27FC236}">
-                <a16:creationId xmlns:a16="http://schemas.microsoft.com/office/drawing/2014/main" id="{0293891A-D4C5-485C-A00A-CFB167D43B6C}"/>
+                <a16:creationId xmlns:a16="http://schemas.microsoft.com/office/drawing/2014/main" id="{17F7587F-41F6-4090-B63C-6D21E5D4E0C2}"/>
               </a:ext>
             </a:extLst>
           </p:cNvPr>
@@ -10691,7 +10807,7 @@
           <p:cNvPr id="9" name="p8-arrow-label">
             <a:extLst xmlns:a="http://schemas.openxmlformats.org/drawingml/2006/main">
               <a:ext uri="{FF2B5EF4-FFF2-40B4-BE49-F238E27FC236}">
-                <a16:creationId xmlns:a16="http://schemas.microsoft.com/office/drawing/2014/main" id="{C557C96C-1BFB-4133-A2A5-7B7D6591AC3D}"/>
+                <a16:creationId xmlns:a16="http://schemas.microsoft.com/office/drawing/2014/main" id="{1A08A8D7-A508-4BC9-A416-C515758637BE}"/>
               </a:ext>
             </a:extLst>
           </p:cNvPr>
@@ -10753,7 +10869,7 @@
           <p:cNvPr id="10" name="p8-arrow">
             <a:extLst xmlns:a="http://schemas.openxmlformats.org/drawingml/2006/main">
               <a:ext uri="{FF2B5EF4-FFF2-40B4-BE49-F238E27FC236}">
-                <a16:creationId xmlns:a16="http://schemas.microsoft.com/office/drawing/2014/main" id="{68B3E045-4F69-497B-AC52-DD4B6F3A1612}"/>
+                <a16:creationId xmlns:a16="http://schemas.microsoft.com/office/drawing/2014/main" id="{7A595ACE-B345-4ECD-8FAE-0259A3848750}"/>
               </a:ext>
             </a:extLst>
           </p:cNvPr>
@@ -10784,7 +10900,7 @@
           <p:cNvPr id="11" name="p8-runtime-title">
             <a:extLst xmlns:a="http://schemas.openxmlformats.org/drawingml/2006/main">
               <a:ext uri="{FF2B5EF4-FFF2-40B4-BE49-F238E27FC236}">
-                <a16:creationId xmlns:a16="http://schemas.microsoft.com/office/drawing/2014/main" id="{1DFCE75D-6DE1-4ECB-B0C6-FA7DA5AC3546}"/>
+                <a16:creationId xmlns:a16="http://schemas.microsoft.com/office/drawing/2014/main" id="{780E5804-FA72-4E9C-ADCE-CC3A5555677A}"/>
               </a:ext>
             </a:extLst>
           </p:cNvPr>
@@ -10846,7 +10962,7 @@
           <p:cNvPr id="12" name="p8-runtime">
             <a:extLst xmlns:a="http://schemas.openxmlformats.org/drawingml/2006/main">
               <a:ext uri="{FF2B5EF4-FFF2-40B4-BE49-F238E27FC236}">
-                <a16:creationId xmlns:a16="http://schemas.microsoft.com/office/drawing/2014/main" id="{10D7A1F1-40E1-4F31-B1DC-A897B09ABCD6}"/>
+                <a16:creationId xmlns:a16="http://schemas.microsoft.com/office/drawing/2014/main" id="{24E87F76-C073-466E-86D2-8B6045B71AC7}"/>
               </a:ext>
             </a:extLst>
           </p:cNvPr>
@@ -10962,19 +11078,19 @@
           <p:cNvPr id="13" name="p8-result">
             <a:extLst xmlns:a="http://schemas.openxmlformats.org/drawingml/2006/main">
               <a:ext uri="{FF2B5EF4-FFF2-40B4-BE49-F238E27FC236}">
-                <a16:creationId xmlns:a16="http://schemas.microsoft.com/office/drawing/2014/main" id="{BDE2A3DC-F7AF-4845-B99A-9365EE2D194D}"/>
-              </a:ext>
-            </a:extLst>
-          </p:cNvPr>
-          <p:cNvSpPr>
-            <a:spLocks xmlns:a="http://schemas.openxmlformats.org/drawingml/2006/main" noGrp="1"/>
-          </p:cNvSpPr>
-          <p:nvPr/>
-        </p:nvSpPr>
-        <p:spPr>
-          <a:xfrm xmlns:a="http://schemas.openxmlformats.org/drawingml/2006/main">
-            <a:off x="7810500" y="4362450"/>
-            <a:ext cx="3429000" cy="419100"/>
+                <a16:creationId xmlns:a16="http://schemas.microsoft.com/office/drawing/2014/main" id="{4B079A8A-FFB8-449D-9BB3-A91F3420BBA5}"/>
+              </a:ext>
+            </a:extLst>
+          </p:cNvPr>
+          <p:cNvSpPr>
+            <a:spLocks xmlns:a="http://schemas.openxmlformats.org/drawingml/2006/main" noGrp="1"/>
+          </p:cNvSpPr>
+          <p:nvPr/>
+        </p:nvSpPr>
+        <p:spPr>
+          <a:xfrm xmlns:a="http://schemas.openxmlformats.org/drawingml/2006/main">
+            <a:off x="7810500" y="4286250"/>
+            <a:ext cx="3429000" cy="685800"/>
           </a:xfrm>
           <a:prstGeom xmlns:a="http://schemas.openxmlformats.org/drawingml/2006/main" prst="rect">
             <a:avLst/>
@@ -11015,6 +11131,33 @@
                 <a:cs typeface="Microsoft YaHei"/>
               </a:rPr>
               <a:t>视觉理解从在线成本变成离线资产。</a:t>
+            </a:r>
+          </a:p>
+          <a:p xmlns:a="http://schemas.openxmlformats.org/drawingml/2006/main">
+            <a:pPr algn="l">
+              <a:lnSpc>
+                <a:spcPct val="140000"/>
+              </a:lnSpc>
+              <a:buNone/>
+              <a:defRPr sz="1200" b="0">
+                <a:solidFill>
+                  <a:srgbClr val="707780"/>
+                </a:solidFill>
+                <a:latin typeface="Microsoft YaHei"/>
+                <a:ea typeface="Microsoft YaHei"/>
+                <a:cs typeface="Microsoft YaHei"/>
+              </a:defRPr>
+            </a:pPr>
+            <a:r>
+              <a:rPr sz="1200" b="0">
+                <a:solidFill>
+                  <a:srgbClr val="707780"/>
+                </a:solidFill>
+                <a:latin typeface="Microsoft YaHei"/>
+                <a:ea typeface="Microsoft YaHei"/>
+                <a:cs typeface="Microsoft YaHei"/>
+              </a:rPr>
+              <a:t>视觉模型服务建设期审查，不成为每次交付的必要成本。</a:t>
             </a:r>
           </a:p>
         </p:txBody>
@@ -11022,7 +11165,7 @@
     </p:spTree>
     <p:extLst>
       <p:ext uri="{BB962C8B-B14F-4D97-AF65-F5344CB8AC3E}">
-        <p14:creationId xmlns:p14="http://schemas.microsoft.com/office/powerpoint/2010/main" val="1560009752"/>
+        <p14:creationId xmlns:p14="http://schemas.microsoft.com/office/powerpoint/2010/main" val="1921322193"/>
       </p:ext>
     </p:extLst>
   </p:cSld>
@@ -11053,7 +11196,7 @@
           <p:cNvPr id="19" name="p9-eyebrow">
             <a:extLst xmlns:a="http://schemas.openxmlformats.org/drawingml/2006/main">
               <a:ext uri="{FF2B5EF4-FFF2-40B4-BE49-F238E27FC236}">
-                <a16:creationId xmlns:a16="http://schemas.microsoft.com/office/drawing/2014/main" id="{736FB370-735A-457F-BB7E-E936CFD2834E}"/>
+                <a16:creationId xmlns:a16="http://schemas.microsoft.com/office/drawing/2014/main" id="{3CAEEA33-A28A-4EA3-A9F2-21090388519F}"/>
               </a:ext>
             </a:extLst>
           </p:cNvPr>
@@ -11087,7 +11230,7 @@
                 <a:spcPct val="140000"/>
               </a:lnSpc>
               <a:buNone/>
-              <a:defRPr sz="900" b="1">
+              <a:defRPr sz="900" b="0">
                 <a:solidFill>
                   <a:srgbClr val="315F91"/>
                 </a:solidFill>
@@ -11097,7 +11240,7 @@
               </a:defRPr>
             </a:pPr>
             <a:r>
-              <a:rPr sz="900" b="1">
+              <a:rPr sz="900" b="0">
                 <a:solidFill>
                   <a:srgbClr val="315F91"/>
                 </a:solidFill>
@@ -11115,7 +11258,7 @@
           <p:cNvPr id="2" name="p9-title">
             <a:extLst xmlns:a="http://schemas.openxmlformats.org/drawingml/2006/main">
               <a:ext uri="{FF2B5EF4-FFF2-40B4-BE49-F238E27FC236}">
-                <a16:creationId xmlns:a16="http://schemas.microsoft.com/office/drawing/2014/main" id="{EF4312B1-5E26-4E5A-ABDA-2E9FCA7618BE}"/>
+                <a16:creationId xmlns:a16="http://schemas.microsoft.com/office/drawing/2014/main" id="{5072DC01-64E2-436D-B9E6-EDB9BE99F337}"/>
               </a:ext>
             </a:extLst>
           </p:cNvPr>
@@ -11177,7 +11320,7 @@
           <p:cNvPr id="3" name="p9-divider">
             <a:extLst xmlns:a="http://schemas.openxmlformats.org/drawingml/2006/main">
               <a:ext uri="{FF2B5EF4-FFF2-40B4-BE49-F238E27FC236}">
-                <a16:creationId xmlns:a16="http://schemas.microsoft.com/office/drawing/2014/main" id="{F13FC52B-6A6B-4CBA-972E-7CA58D2DDEAA}"/>
+                <a16:creationId xmlns:a16="http://schemas.microsoft.com/office/drawing/2014/main" id="{988B73E5-793F-45C5-86CD-6F67D1148648}"/>
               </a:ext>
             </a:extLst>
           </p:cNvPr>
@@ -11208,7 +11351,7 @@
           <p:cNvPr id="4" name="p9-footer">
             <a:extLst xmlns:a="http://schemas.openxmlformats.org/drawingml/2006/main">
               <a:ext uri="{FF2B5EF4-FFF2-40B4-BE49-F238E27FC236}">
-                <a16:creationId xmlns:a16="http://schemas.microsoft.com/office/drawing/2014/main" id="{457590D4-3A27-4FC2-A091-E1CFEFD41EA0}"/>
+                <a16:creationId xmlns:a16="http://schemas.microsoft.com/office/drawing/2014/main" id="{DA8192F3-169C-4C90-92C2-BEAD9192D483}"/>
               </a:ext>
             </a:extLst>
           </p:cNvPr>
@@ -11270,7 +11413,7 @@
           <p:cNvPr id="5" name="p9-intro">
             <a:extLst xmlns:a="http://schemas.openxmlformats.org/drawingml/2006/main">
               <a:ext uri="{FF2B5EF4-FFF2-40B4-BE49-F238E27FC236}">
-                <a16:creationId xmlns:a16="http://schemas.microsoft.com/office/drawing/2014/main" id="{A49E46A4-3FCB-4F05-860E-C9A463716950}"/>
+                <a16:creationId xmlns:a16="http://schemas.microsoft.com/office/drawing/2014/main" id="{D6CEAFD0-9E14-4EAF-AC4C-12818C7F2BF9}"/>
               </a:ext>
             </a:extLst>
           </p:cNvPr>
@@ -11332,7 +11475,7 @@
           <p:cNvPr id="6" name="p9-layer-0">
             <a:extLst xmlns:a="http://schemas.openxmlformats.org/drawingml/2006/main">
               <a:ext uri="{FF2B5EF4-FFF2-40B4-BE49-F238E27FC236}">
-                <a16:creationId xmlns:a16="http://schemas.microsoft.com/office/drawing/2014/main" id="{584CCBCF-792A-4140-95E4-52020EBAC5D7}"/>
+                <a16:creationId xmlns:a16="http://schemas.microsoft.com/office/drawing/2014/main" id="{F8FC5096-71B0-4063-B22E-7EEC76B45030}"/>
               </a:ext>
             </a:extLst>
           </p:cNvPr>
@@ -11363,7 +11506,7 @@
           <p:cNvPr id="7" name="p9-layer-0-title">
             <a:extLst xmlns:a="http://schemas.openxmlformats.org/drawingml/2006/main">
               <a:ext uri="{FF2B5EF4-FFF2-40B4-BE49-F238E27FC236}">
-                <a16:creationId xmlns:a16="http://schemas.microsoft.com/office/drawing/2014/main" id="{CE55E7DF-907B-40A3-A2BC-724A081C9057}"/>
+                <a16:creationId xmlns:a16="http://schemas.microsoft.com/office/drawing/2014/main" id="{382A22B6-4C70-4DBC-9D9D-6E313D1DDA93}"/>
               </a:ext>
             </a:extLst>
           </p:cNvPr>
@@ -11425,7 +11568,7 @@
           <p:cNvPr id="8" name="p9-layer-0-items">
             <a:extLst xmlns:a="http://schemas.openxmlformats.org/drawingml/2006/main">
               <a:ext uri="{FF2B5EF4-FFF2-40B4-BE49-F238E27FC236}">
-                <a16:creationId xmlns:a16="http://schemas.microsoft.com/office/drawing/2014/main" id="{39F68CDB-1354-4933-B4E3-23E1C18DD723}"/>
+                <a16:creationId xmlns:a16="http://schemas.microsoft.com/office/drawing/2014/main" id="{E5831CD0-7EB4-46FC-99BF-7BF96D18E7C8}"/>
               </a:ext>
             </a:extLst>
           </p:cNvPr>
@@ -11487,7 +11630,7 @@
           <p:cNvPr id="9" name="p9-layer-1">
             <a:extLst xmlns:a="http://schemas.openxmlformats.org/drawingml/2006/main">
               <a:ext uri="{FF2B5EF4-FFF2-40B4-BE49-F238E27FC236}">
-                <a16:creationId xmlns:a16="http://schemas.microsoft.com/office/drawing/2014/main" id="{1D465221-F165-463C-A149-BA5AE5534B43}"/>
+                <a16:creationId xmlns:a16="http://schemas.microsoft.com/office/drawing/2014/main" id="{F430530E-DD58-44C0-BE4A-FDDC2E42F517}"/>
               </a:ext>
             </a:extLst>
           </p:cNvPr>
@@ -11518,7 +11661,7 @@
           <p:cNvPr id="10" name="p9-layer-1-title">
             <a:extLst xmlns:a="http://schemas.openxmlformats.org/drawingml/2006/main">
               <a:ext uri="{FF2B5EF4-FFF2-40B4-BE49-F238E27FC236}">
-                <a16:creationId xmlns:a16="http://schemas.microsoft.com/office/drawing/2014/main" id="{AE57A477-3D8F-4570-BF50-12CE582E650A}"/>
+                <a16:creationId xmlns:a16="http://schemas.microsoft.com/office/drawing/2014/main" id="{B197E237-B83D-4D0A-A667-732A69479637}"/>
               </a:ext>
             </a:extLst>
           </p:cNvPr>
@@ -11580,7 +11723,7 @@
           <p:cNvPr id="11" name="p9-layer-1-items">
             <a:extLst xmlns:a="http://schemas.openxmlformats.org/drawingml/2006/main">
               <a:ext uri="{FF2B5EF4-FFF2-40B4-BE49-F238E27FC236}">
-                <a16:creationId xmlns:a16="http://schemas.microsoft.com/office/drawing/2014/main" id="{AB019877-FFE4-4403-9CC2-E56D9C4E3FEE}"/>
+                <a16:creationId xmlns:a16="http://schemas.microsoft.com/office/drawing/2014/main" id="{A57FF7D2-9318-4344-9D9C-51090CDAF7EC}"/>
               </a:ext>
             </a:extLst>
           </p:cNvPr>
@@ -11642,7 +11785,7 @@
           <p:cNvPr id="12" name="p9-layer-2">
             <a:extLst xmlns:a="http://schemas.openxmlformats.org/drawingml/2006/main">
               <a:ext uri="{FF2B5EF4-FFF2-40B4-BE49-F238E27FC236}">
-                <a16:creationId xmlns:a16="http://schemas.microsoft.com/office/drawing/2014/main" id="{F0328E16-0F61-4F24-B3E3-290CC0F49B03}"/>
+                <a16:creationId xmlns:a16="http://schemas.microsoft.com/office/drawing/2014/main" id="{34713F06-5DF5-411B-8A9F-C0F056590114}"/>
               </a:ext>
             </a:extLst>
           </p:cNvPr>
@@ -11673,7 +11816,7 @@
           <p:cNvPr id="13" name="p9-layer-2-title">
             <a:extLst xmlns:a="http://schemas.openxmlformats.org/drawingml/2006/main">
               <a:ext uri="{FF2B5EF4-FFF2-40B4-BE49-F238E27FC236}">
-                <a16:creationId xmlns:a16="http://schemas.microsoft.com/office/drawing/2014/main" id="{DCAD12DB-9AAE-47BE-951D-4CBC165D9308}"/>
+                <a16:creationId xmlns:a16="http://schemas.microsoft.com/office/drawing/2014/main" id="{44A557A6-0ABB-46C3-93AC-55AA015A8CB0}"/>
               </a:ext>
             </a:extLst>
           </p:cNvPr>
@@ -11735,7 +11878,7 @@
           <p:cNvPr id="14" name="p9-layer-2-items">
             <a:extLst xmlns:a="http://schemas.openxmlformats.org/drawingml/2006/main">
               <a:ext uri="{FF2B5EF4-FFF2-40B4-BE49-F238E27FC236}">
-                <a16:creationId xmlns:a16="http://schemas.microsoft.com/office/drawing/2014/main" id="{DC0D7A4C-A3F7-4DEE-AAC2-DB47D548D4E9}"/>
+                <a16:creationId xmlns:a16="http://schemas.microsoft.com/office/drawing/2014/main" id="{2C85DF03-DAA4-4169-A2DE-98B09B1FE93D}"/>
               </a:ext>
             </a:extLst>
           </p:cNvPr>
@@ -11797,7 +11940,7 @@
           <p:cNvPr id="15" name="p9-layer-3">
             <a:extLst xmlns:a="http://schemas.openxmlformats.org/drawingml/2006/main">
               <a:ext uri="{FF2B5EF4-FFF2-40B4-BE49-F238E27FC236}">
-                <a16:creationId xmlns:a16="http://schemas.microsoft.com/office/drawing/2014/main" id="{5A77B20B-B91D-4A72-A52C-2C729B50D997}"/>
+                <a16:creationId xmlns:a16="http://schemas.microsoft.com/office/drawing/2014/main" id="{88E8A964-DD24-48CF-90FA-2805B33CA962}"/>
               </a:ext>
             </a:extLst>
           </p:cNvPr>
@@ -11828,7 +11971,7 @@
           <p:cNvPr id="16" name="p9-layer-3-title">
             <a:extLst xmlns:a="http://schemas.openxmlformats.org/drawingml/2006/main">
               <a:ext uri="{FF2B5EF4-FFF2-40B4-BE49-F238E27FC236}">
-                <a16:creationId xmlns:a16="http://schemas.microsoft.com/office/drawing/2014/main" id="{763680D6-5534-4A4F-9C81-02528B853FB8}"/>
+                <a16:creationId xmlns:a16="http://schemas.microsoft.com/office/drawing/2014/main" id="{DEA34921-7CFC-4B02-A32B-5D79B37CCFE0}"/>
               </a:ext>
             </a:extLst>
           </p:cNvPr>
@@ -11890,7 +12033,7 @@
           <p:cNvPr id="17" name="p9-layer-3-items">
             <a:extLst xmlns:a="http://schemas.openxmlformats.org/drawingml/2006/main">
               <a:ext uri="{FF2B5EF4-FFF2-40B4-BE49-F238E27FC236}">
-                <a16:creationId xmlns:a16="http://schemas.microsoft.com/office/drawing/2014/main" id="{6A6BA98B-45D2-490E-A7EC-A6116D655C17}"/>
+                <a16:creationId xmlns:a16="http://schemas.microsoft.com/office/drawing/2014/main" id="{F81C85A1-8509-4443-B813-9B42C61BC15C}"/>
               </a:ext>
             </a:extLst>
           </p:cNvPr>
@@ -11952,7 +12095,7 @@
           <p:cNvPr id="18" name="p9-note">
             <a:extLst xmlns:a="http://schemas.openxmlformats.org/drawingml/2006/main">
               <a:ext uri="{FF2B5EF4-FFF2-40B4-BE49-F238E27FC236}">
-                <a16:creationId xmlns:a16="http://schemas.microsoft.com/office/drawing/2014/main" id="{02EBF51F-E626-4792-8E31-50688A8696F7}"/>
+                <a16:creationId xmlns:a16="http://schemas.microsoft.com/office/drawing/2014/main" id="{F4EC62C3-48CE-4838-B5D2-4AD686B26026}"/>
               </a:ext>
             </a:extLst>
           </p:cNvPr>
@@ -12012,7 +12155,7 @@
     </p:spTree>
     <p:extLst>
       <p:ext uri="{BB962C8B-B14F-4D97-AF65-F5344CB8AC3E}">
-        <p14:creationId xmlns:p14="http://schemas.microsoft.com/office/powerpoint/2010/main" val="543868139"/>
+        <p14:creationId xmlns:p14="http://schemas.microsoft.com/office/powerpoint/2010/main" val="77977715"/>
       </p:ext>
     </p:extLst>
   </p:cSld>

</xml_diff>